<commit_message>
added working model of battery from previous documentation, suggested ways to document it
</commit_message>
<xml_diff>
--- a/Documentation/CDCM Diagrams .pptx
+++ b/Documentation/CDCM Diagrams .pptx
@@ -4,8 +4,13 @@
   <p:sldMasterIdLst>
     <p:sldMasterId id="2147483648" r:id="rId1"/>
   </p:sldMasterIdLst>
+  <p:notesMasterIdLst>
+    <p:notesMasterId r:id="rId5"/>
+  </p:notesMasterIdLst>
   <p:sldIdLst>
     <p:sldId id="256" r:id="rId2"/>
+    <p:sldId id="258" r:id="rId3"/>
+    <p:sldId id="257" r:id="rId4"/>
   </p:sldIdLst>
   <p:sldSz cx="12192000" cy="6858000"/>
   <p:notesSz cx="6858000" cy="9144000"/>
@@ -104,7 +109,445 @@
       </a:defRPr>
     </a:lvl9pPr>
   </p:defaultTextStyle>
+  <p:extLst>
+    <p:ext uri="{EFAFB233-063F-42B5-8137-9DF3F51BA10A}">
+      <p15:sldGuideLst xmlns:p15="http://schemas.microsoft.com/office/powerpoint/2012/main"/>
+    </p:ext>
+  </p:extLst>
 </p:presentation>
+</file>
+
+<file path=ppt/notesMasters/notesMaster1.xml><?xml version="1.0" encoding="utf-8"?>
+<p:notesMaster xmlns:a="http://schemas.openxmlformats.org/drawingml/2006/main" xmlns:r="http://schemas.openxmlformats.org/officeDocument/2006/relationships" xmlns:p="http://schemas.openxmlformats.org/presentationml/2006/main">
+  <p:cSld>
+    <p:bg>
+      <p:bgRef idx="1001">
+        <a:schemeClr val="bg1"/>
+      </p:bgRef>
+    </p:bg>
+    <p:spTree>
+      <p:nvGrpSpPr>
+        <p:cNvPr id="1" name=""/>
+        <p:cNvGrpSpPr/>
+        <p:nvPr/>
+      </p:nvGrpSpPr>
+      <p:grpSpPr>
+        <a:xfrm>
+          <a:off x="0" y="0"/>
+          <a:ext cx="0" cy="0"/>
+          <a:chOff x="0" y="0"/>
+          <a:chExt cx="0" cy="0"/>
+        </a:xfrm>
+      </p:grpSpPr>
+      <p:sp>
+        <p:nvSpPr>
+          <p:cNvPr id="2" name="Header Placeholder 1"/>
+          <p:cNvSpPr>
+            <a:spLocks noGrp="1"/>
+          </p:cNvSpPr>
+          <p:nvPr>
+            <p:ph type="hdr" sz="quarter"/>
+          </p:nvPr>
+        </p:nvSpPr>
+        <p:spPr>
+          <a:xfrm>
+            <a:off x="0" y="0"/>
+            <a:ext cx="2971800" cy="458788"/>
+          </a:xfrm>
+          <a:prstGeom prst="rect">
+            <a:avLst/>
+          </a:prstGeom>
+        </p:spPr>
+        <p:txBody>
+          <a:bodyPr vert="horz" lIns="91440" tIns="45720" rIns="91440" bIns="45720" rtlCol="0"/>
+          <a:lstStyle>
+            <a:lvl1pPr algn="l">
+              <a:defRPr sz="1200"/>
+            </a:lvl1pPr>
+          </a:lstStyle>
+          <a:p>
+            <a:endParaRPr lang="en-US"/>
+          </a:p>
+        </p:txBody>
+      </p:sp>
+      <p:sp>
+        <p:nvSpPr>
+          <p:cNvPr id="3" name="Date Placeholder 2"/>
+          <p:cNvSpPr>
+            <a:spLocks noGrp="1"/>
+          </p:cNvSpPr>
+          <p:nvPr>
+            <p:ph type="dt" idx="1"/>
+          </p:nvPr>
+        </p:nvSpPr>
+        <p:spPr>
+          <a:xfrm>
+            <a:off x="3884613" y="0"/>
+            <a:ext cx="2971800" cy="458788"/>
+          </a:xfrm>
+          <a:prstGeom prst="rect">
+            <a:avLst/>
+          </a:prstGeom>
+        </p:spPr>
+        <p:txBody>
+          <a:bodyPr vert="horz" lIns="91440" tIns="45720" rIns="91440" bIns="45720" rtlCol="0"/>
+          <a:lstStyle>
+            <a:lvl1pPr algn="r">
+              <a:defRPr sz="1200"/>
+            </a:lvl1pPr>
+          </a:lstStyle>
+          <a:p>
+            <a:fld id="{94EF214D-1F76-F841-A2D3-D2CDEC996226}" type="datetimeFigureOut">
+              <a:rPr lang="en-US" smtClean="0"/>
+              <a:t>8/11/25</a:t>
+            </a:fld>
+            <a:endParaRPr lang="en-US"/>
+          </a:p>
+        </p:txBody>
+      </p:sp>
+      <p:sp>
+        <p:nvSpPr>
+          <p:cNvPr id="4" name="Slide Image Placeholder 3"/>
+          <p:cNvSpPr>
+            <a:spLocks noGrp="1" noRot="1" noChangeAspect="1"/>
+          </p:cNvSpPr>
+          <p:nvPr>
+            <p:ph type="sldImg" idx="2"/>
+          </p:nvPr>
+        </p:nvSpPr>
+        <p:spPr>
+          <a:xfrm>
+            <a:off x="685800" y="1143000"/>
+            <a:ext cx="5486400" cy="3086100"/>
+          </a:xfrm>
+          <a:prstGeom prst="rect">
+            <a:avLst/>
+          </a:prstGeom>
+          <a:noFill/>
+          <a:ln w="12700">
+            <a:solidFill>
+              <a:prstClr val="black"/>
+            </a:solidFill>
+          </a:ln>
+        </p:spPr>
+        <p:txBody>
+          <a:bodyPr vert="horz" lIns="91440" tIns="45720" rIns="91440" bIns="45720" rtlCol="0" anchor="ctr"/>
+          <a:lstStyle/>
+          <a:p>
+            <a:endParaRPr lang="en-US"/>
+          </a:p>
+        </p:txBody>
+      </p:sp>
+      <p:sp>
+        <p:nvSpPr>
+          <p:cNvPr id="5" name="Notes Placeholder 4"/>
+          <p:cNvSpPr>
+            <a:spLocks noGrp="1"/>
+          </p:cNvSpPr>
+          <p:nvPr>
+            <p:ph type="body" sz="quarter" idx="3"/>
+          </p:nvPr>
+        </p:nvSpPr>
+        <p:spPr>
+          <a:xfrm>
+            <a:off x="685800" y="4400550"/>
+            <a:ext cx="5486400" cy="3600450"/>
+          </a:xfrm>
+          <a:prstGeom prst="rect">
+            <a:avLst/>
+          </a:prstGeom>
+        </p:spPr>
+        <p:txBody>
+          <a:bodyPr vert="horz" lIns="91440" tIns="45720" rIns="91440" bIns="45720" rtlCol="0"/>
+          <a:lstStyle/>
+          <a:p>
+            <a:pPr lvl="0"/>
+            <a:r>
+              <a:rPr lang="en-US"/>
+              <a:t>Click to edit Master text styles</a:t>
+            </a:r>
+          </a:p>
+          <a:p>
+            <a:pPr lvl="1"/>
+            <a:r>
+              <a:rPr lang="en-US"/>
+              <a:t>Second level</a:t>
+            </a:r>
+          </a:p>
+          <a:p>
+            <a:pPr lvl="2"/>
+            <a:r>
+              <a:rPr lang="en-US"/>
+              <a:t>Third level</a:t>
+            </a:r>
+          </a:p>
+          <a:p>
+            <a:pPr lvl="3"/>
+            <a:r>
+              <a:rPr lang="en-US"/>
+              <a:t>Fourth level</a:t>
+            </a:r>
+          </a:p>
+          <a:p>
+            <a:pPr lvl="4"/>
+            <a:r>
+              <a:rPr lang="en-US"/>
+              <a:t>Fifth level</a:t>
+            </a:r>
+          </a:p>
+        </p:txBody>
+      </p:sp>
+      <p:sp>
+        <p:nvSpPr>
+          <p:cNvPr id="6" name="Footer Placeholder 5"/>
+          <p:cNvSpPr>
+            <a:spLocks noGrp="1"/>
+          </p:cNvSpPr>
+          <p:nvPr>
+            <p:ph type="ftr" sz="quarter" idx="4"/>
+          </p:nvPr>
+        </p:nvSpPr>
+        <p:spPr>
+          <a:xfrm>
+            <a:off x="0" y="8685213"/>
+            <a:ext cx="2971800" cy="458787"/>
+          </a:xfrm>
+          <a:prstGeom prst="rect">
+            <a:avLst/>
+          </a:prstGeom>
+        </p:spPr>
+        <p:txBody>
+          <a:bodyPr vert="horz" lIns="91440" tIns="45720" rIns="91440" bIns="45720" rtlCol="0" anchor="b"/>
+          <a:lstStyle>
+            <a:lvl1pPr algn="l">
+              <a:defRPr sz="1200"/>
+            </a:lvl1pPr>
+          </a:lstStyle>
+          <a:p>
+            <a:endParaRPr lang="en-US"/>
+          </a:p>
+        </p:txBody>
+      </p:sp>
+      <p:sp>
+        <p:nvSpPr>
+          <p:cNvPr id="7" name="Slide Number Placeholder 6"/>
+          <p:cNvSpPr>
+            <a:spLocks noGrp="1"/>
+          </p:cNvSpPr>
+          <p:nvPr>
+            <p:ph type="sldNum" sz="quarter" idx="5"/>
+          </p:nvPr>
+        </p:nvSpPr>
+        <p:spPr>
+          <a:xfrm>
+            <a:off x="3884613" y="8685213"/>
+            <a:ext cx="2971800" cy="458787"/>
+          </a:xfrm>
+          <a:prstGeom prst="rect">
+            <a:avLst/>
+          </a:prstGeom>
+        </p:spPr>
+        <p:txBody>
+          <a:bodyPr vert="horz" lIns="91440" tIns="45720" rIns="91440" bIns="45720" rtlCol="0" anchor="b"/>
+          <a:lstStyle>
+            <a:lvl1pPr algn="r">
+              <a:defRPr sz="1200"/>
+            </a:lvl1pPr>
+          </a:lstStyle>
+          <a:p>
+            <a:fld id="{D38F2629-DFF2-3040-B162-07C266238A5B}" type="slidenum">
+              <a:rPr lang="en-US" smtClean="0"/>
+              <a:t>‹#›</a:t>
+            </a:fld>
+            <a:endParaRPr lang="en-US"/>
+          </a:p>
+        </p:txBody>
+      </p:sp>
+    </p:spTree>
+    <p:extLst>
+      <p:ext uri="{BB962C8B-B14F-4D97-AF65-F5344CB8AC3E}">
+        <p14:creationId xmlns:p14="http://schemas.microsoft.com/office/powerpoint/2010/main" val="1538957056"/>
+      </p:ext>
+    </p:extLst>
+  </p:cSld>
+  <p:clrMap bg1="lt1" tx1="dk1" bg2="lt2" tx2="dk2" accent1="accent1" accent2="accent2" accent3="accent3" accent4="accent4" accent5="accent5" accent6="accent6" hlink="hlink" folHlink="folHlink"/>
+  <p:notesStyle>
+    <a:lvl1pPr marL="0" algn="l" defTabSz="914400" rtl="0" eaLnBrk="1" latinLnBrk="0" hangingPunct="1">
+      <a:defRPr sz="1200" kern="1200">
+        <a:solidFill>
+          <a:schemeClr val="tx1"/>
+        </a:solidFill>
+        <a:latin typeface="+mn-lt"/>
+        <a:ea typeface="+mn-ea"/>
+        <a:cs typeface="+mn-cs"/>
+      </a:defRPr>
+    </a:lvl1pPr>
+    <a:lvl2pPr marL="457200" algn="l" defTabSz="914400" rtl="0" eaLnBrk="1" latinLnBrk="0" hangingPunct="1">
+      <a:defRPr sz="1200" kern="1200">
+        <a:solidFill>
+          <a:schemeClr val="tx1"/>
+        </a:solidFill>
+        <a:latin typeface="+mn-lt"/>
+        <a:ea typeface="+mn-ea"/>
+        <a:cs typeface="+mn-cs"/>
+      </a:defRPr>
+    </a:lvl2pPr>
+    <a:lvl3pPr marL="914400" algn="l" defTabSz="914400" rtl="0" eaLnBrk="1" latinLnBrk="0" hangingPunct="1">
+      <a:defRPr sz="1200" kern="1200">
+        <a:solidFill>
+          <a:schemeClr val="tx1"/>
+        </a:solidFill>
+        <a:latin typeface="+mn-lt"/>
+        <a:ea typeface="+mn-ea"/>
+        <a:cs typeface="+mn-cs"/>
+      </a:defRPr>
+    </a:lvl3pPr>
+    <a:lvl4pPr marL="1371600" algn="l" defTabSz="914400" rtl="0" eaLnBrk="1" latinLnBrk="0" hangingPunct="1">
+      <a:defRPr sz="1200" kern="1200">
+        <a:solidFill>
+          <a:schemeClr val="tx1"/>
+        </a:solidFill>
+        <a:latin typeface="+mn-lt"/>
+        <a:ea typeface="+mn-ea"/>
+        <a:cs typeface="+mn-cs"/>
+      </a:defRPr>
+    </a:lvl4pPr>
+    <a:lvl5pPr marL="1828800" algn="l" defTabSz="914400" rtl="0" eaLnBrk="1" latinLnBrk="0" hangingPunct="1">
+      <a:defRPr sz="1200" kern="1200">
+        <a:solidFill>
+          <a:schemeClr val="tx1"/>
+        </a:solidFill>
+        <a:latin typeface="+mn-lt"/>
+        <a:ea typeface="+mn-ea"/>
+        <a:cs typeface="+mn-cs"/>
+      </a:defRPr>
+    </a:lvl5pPr>
+    <a:lvl6pPr marL="2286000" algn="l" defTabSz="914400" rtl="0" eaLnBrk="1" latinLnBrk="0" hangingPunct="1">
+      <a:defRPr sz="1200" kern="1200">
+        <a:solidFill>
+          <a:schemeClr val="tx1"/>
+        </a:solidFill>
+        <a:latin typeface="+mn-lt"/>
+        <a:ea typeface="+mn-ea"/>
+        <a:cs typeface="+mn-cs"/>
+      </a:defRPr>
+    </a:lvl6pPr>
+    <a:lvl7pPr marL="2743200" algn="l" defTabSz="914400" rtl="0" eaLnBrk="1" latinLnBrk="0" hangingPunct="1">
+      <a:defRPr sz="1200" kern="1200">
+        <a:solidFill>
+          <a:schemeClr val="tx1"/>
+        </a:solidFill>
+        <a:latin typeface="+mn-lt"/>
+        <a:ea typeface="+mn-ea"/>
+        <a:cs typeface="+mn-cs"/>
+      </a:defRPr>
+    </a:lvl7pPr>
+    <a:lvl8pPr marL="3200400" algn="l" defTabSz="914400" rtl="0" eaLnBrk="1" latinLnBrk="0" hangingPunct="1">
+      <a:defRPr sz="1200" kern="1200">
+        <a:solidFill>
+          <a:schemeClr val="tx1"/>
+        </a:solidFill>
+        <a:latin typeface="+mn-lt"/>
+        <a:ea typeface="+mn-ea"/>
+        <a:cs typeface="+mn-cs"/>
+      </a:defRPr>
+    </a:lvl8pPr>
+    <a:lvl9pPr marL="3657600" algn="l" defTabSz="914400" rtl="0" eaLnBrk="1" latinLnBrk="0" hangingPunct="1">
+      <a:defRPr sz="1200" kern="1200">
+        <a:solidFill>
+          <a:schemeClr val="tx1"/>
+        </a:solidFill>
+        <a:latin typeface="+mn-lt"/>
+        <a:ea typeface="+mn-ea"/>
+        <a:cs typeface="+mn-cs"/>
+      </a:defRPr>
+    </a:lvl9pPr>
+  </p:notesStyle>
+</p:notesMaster>
+</file>
+
+<file path=ppt/notesSlides/notesSlide1.xml><?xml version="1.0" encoding="utf-8"?>
+<p:notes xmlns:a="http://schemas.openxmlformats.org/drawingml/2006/main" xmlns:r="http://schemas.openxmlformats.org/officeDocument/2006/relationships" xmlns:p="http://schemas.openxmlformats.org/presentationml/2006/main">
+  <p:cSld>
+    <p:spTree>
+      <p:nvGrpSpPr>
+        <p:cNvPr id="1" name=""/>
+        <p:cNvGrpSpPr/>
+        <p:nvPr/>
+      </p:nvGrpSpPr>
+      <p:grpSpPr>
+        <a:xfrm>
+          <a:off x="0" y="0"/>
+          <a:ext cx="0" cy="0"/>
+          <a:chOff x="0" y="0"/>
+          <a:chExt cx="0" cy="0"/>
+        </a:xfrm>
+      </p:grpSpPr>
+      <p:sp>
+        <p:nvSpPr>
+          <p:cNvPr id="2" name="Slide Image Placeholder 1"/>
+          <p:cNvSpPr>
+            <a:spLocks noGrp="1" noRot="1" noChangeAspect="1"/>
+          </p:cNvSpPr>
+          <p:nvPr>
+            <p:ph type="sldImg"/>
+          </p:nvPr>
+        </p:nvSpPr>
+        <p:spPr/>
+      </p:sp>
+      <p:sp>
+        <p:nvSpPr>
+          <p:cNvPr id="3" name="Notes Placeholder 2"/>
+          <p:cNvSpPr>
+            <a:spLocks noGrp="1"/>
+          </p:cNvSpPr>
+          <p:nvPr>
+            <p:ph type="body" idx="1"/>
+          </p:nvPr>
+        </p:nvSpPr>
+        <p:spPr/>
+        <p:txBody>
+          <a:bodyPr/>
+          <a:lstStyle/>
+          <a:p>
+            <a:endParaRPr lang="en-US" dirty="0"/>
+          </a:p>
+        </p:txBody>
+      </p:sp>
+      <p:sp>
+        <p:nvSpPr>
+          <p:cNvPr id="4" name="Slide Number Placeholder 3"/>
+          <p:cNvSpPr>
+            <a:spLocks noGrp="1"/>
+          </p:cNvSpPr>
+          <p:nvPr>
+            <p:ph type="sldNum" sz="quarter" idx="5"/>
+          </p:nvPr>
+        </p:nvSpPr>
+        <p:spPr/>
+        <p:txBody>
+          <a:bodyPr/>
+          <a:lstStyle/>
+          <a:p>
+            <a:fld id="{D38F2629-DFF2-3040-B162-07C266238A5B}" type="slidenum">
+              <a:rPr lang="en-US" smtClean="0"/>
+              <a:t>2</a:t>
+            </a:fld>
+            <a:endParaRPr lang="en-US"/>
+          </a:p>
+        </p:txBody>
+      </p:sp>
+    </p:spTree>
+    <p:extLst>
+      <p:ext uri="{BB962C8B-B14F-4D97-AF65-F5344CB8AC3E}">
+        <p14:creationId xmlns:p14="http://schemas.microsoft.com/office/powerpoint/2010/main" val="2194631338"/>
+      </p:ext>
+    </p:extLst>
+  </p:cSld>
+  <p:clrMapOvr>
+    <a:masterClrMapping/>
+  </p:clrMapOvr>
+</p:notes>
 </file>
 
 <file path=ppt/slideLayouts/slideLayout1.xml><?xml version="1.0" encoding="utf-8"?>
@@ -254,7 +697,7 @@
           <a:p>
             <a:fld id="{E90F38FF-858C-0643-98FD-89636F5F9C82}" type="datetimeFigureOut">
               <a:rPr lang="en-US" smtClean="0"/>
-              <a:t>8/8/25</a:t>
+              <a:t>8/11/25</a:t>
             </a:fld>
             <a:endParaRPr lang="en-US"/>
           </a:p>
@@ -452,7 +895,7 @@
           <a:p>
             <a:fld id="{E90F38FF-858C-0643-98FD-89636F5F9C82}" type="datetimeFigureOut">
               <a:rPr lang="en-US" smtClean="0"/>
-              <a:t>8/8/25</a:t>
+              <a:t>8/11/25</a:t>
             </a:fld>
             <a:endParaRPr lang="en-US"/>
           </a:p>
@@ -660,7 +1103,7 @@
           <a:p>
             <a:fld id="{E90F38FF-858C-0643-98FD-89636F5F9C82}" type="datetimeFigureOut">
               <a:rPr lang="en-US" smtClean="0"/>
-              <a:t>8/8/25</a:t>
+              <a:t>8/11/25</a:t>
             </a:fld>
             <a:endParaRPr lang="en-US"/>
           </a:p>
@@ -858,7 +1301,7 @@
           <a:p>
             <a:fld id="{E90F38FF-858C-0643-98FD-89636F5F9C82}" type="datetimeFigureOut">
               <a:rPr lang="en-US" smtClean="0"/>
-              <a:t>8/8/25</a:t>
+              <a:t>8/11/25</a:t>
             </a:fld>
             <a:endParaRPr lang="en-US"/>
           </a:p>
@@ -1133,7 +1576,7 @@
           <a:p>
             <a:fld id="{E90F38FF-858C-0643-98FD-89636F5F9C82}" type="datetimeFigureOut">
               <a:rPr lang="en-US" smtClean="0"/>
-              <a:t>8/8/25</a:t>
+              <a:t>8/11/25</a:t>
             </a:fld>
             <a:endParaRPr lang="en-US"/>
           </a:p>
@@ -1398,7 +1841,7 @@
           <a:p>
             <a:fld id="{E90F38FF-858C-0643-98FD-89636F5F9C82}" type="datetimeFigureOut">
               <a:rPr lang="en-US" smtClean="0"/>
-              <a:t>8/8/25</a:t>
+              <a:t>8/11/25</a:t>
             </a:fld>
             <a:endParaRPr lang="en-US"/>
           </a:p>
@@ -1810,7 +2253,7 @@
           <a:p>
             <a:fld id="{E90F38FF-858C-0643-98FD-89636F5F9C82}" type="datetimeFigureOut">
               <a:rPr lang="en-US" smtClean="0"/>
-              <a:t>8/8/25</a:t>
+              <a:t>8/11/25</a:t>
             </a:fld>
             <a:endParaRPr lang="en-US"/>
           </a:p>
@@ -1951,7 +2394,7 @@
           <a:p>
             <a:fld id="{E90F38FF-858C-0643-98FD-89636F5F9C82}" type="datetimeFigureOut">
               <a:rPr lang="en-US" smtClean="0"/>
-              <a:t>8/8/25</a:t>
+              <a:t>8/11/25</a:t>
             </a:fld>
             <a:endParaRPr lang="en-US"/>
           </a:p>
@@ -2064,7 +2507,7 @@
           <a:p>
             <a:fld id="{E90F38FF-858C-0643-98FD-89636F5F9C82}" type="datetimeFigureOut">
               <a:rPr lang="en-US" smtClean="0"/>
-              <a:t>8/8/25</a:t>
+              <a:t>8/11/25</a:t>
             </a:fld>
             <a:endParaRPr lang="en-US"/>
           </a:p>
@@ -2375,7 +2818,7 @@
           <a:p>
             <a:fld id="{E90F38FF-858C-0643-98FD-89636F5F9C82}" type="datetimeFigureOut">
               <a:rPr lang="en-US" smtClean="0"/>
-              <a:t>8/8/25</a:t>
+              <a:t>8/11/25</a:t>
             </a:fld>
             <a:endParaRPr lang="en-US"/>
           </a:p>
@@ -2663,7 +3106,7 @@
           <a:p>
             <a:fld id="{E90F38FF-858C-0643-98FD-89636F5F9C82}" type="datetimeFigureOut">
               <a:rPr lang="en-US" smtClean="0"/>
-              <a:t>8/8/25</a:t>
+              <a:t>8/11/25</a:t>
             </a:fld>
             <a:endParaRPr lang="en-US"/>
           </a:p>
@@ -2904,7 +3347,7 @@
           <a:p>
             <a:fld id="{E90F38FF-858C-0643-98FD-89636F5F9C82}" type="datetimeFigureOut">
               <a:rPr lang="en-US" smtClean="0"/>
-              <a:t>8/8/25</a:t>
+              <a:t>8/11/25</a:t>
             </a:fld>
             <a:endParaRPr lang="en-US"/>
           </a:p>
@@ -4313,10 +4756,1504 @@
           </a:p>
         </p:txBody>
       </p:sp>
+      <p:sp>
+        <p:nvSpPr>
+          <p:cNvPr id="2" name="TextBox 1">
+            <a:extLst>
+              <a:ext uri="{FF2B5EF4-FFF2-40B4-BE49-F238E27FC236}">
+                <a16:creationId xmlns:a16="http://schemas.microsoft.com/office/drawing/2014/main" id="{1AC286A1-0FB4-012E-E44B-50F564292BED}"/>
+              </a:ext>
+            </a:extLst>
+          </p:cNvPr>
+          <p:cNvSpPr txBox="1"/>
+          <p:nvPr/>
+        </p:nvSpPr>
+        <p:spPr>
+          <a:xfrm>
+            <a:off x="11440886" y="6368535"/>
+            <a:ext cx="510076" cy="369332"/>
+          </a:xfrm>
+          <a:prstGeom prst="rect">
+            <a:avLst/>
+          </a:prstGeom>
+          <a:noFill/>
+        </p:spPr>
+        <p:txBody>
+          <a:bodyPr wrap="none" rtlCol="0">
+            <a:spAutoFit/>
+          </a:bodyPr>
+          <a:lstStyle/>
+          <a:p>
+            <a:r>
+              <a:rPr lang="en-US" dirty="0"/>
+              <a:t>8/9</a:t>
+            </a:r>
+          </a:p>
+        </p:txBody>
+      </p:sp>
     </p:spTree>
     <p:extLst>
       <p:ext uri="{BB962C8B-B14F-4D97-AF65-F5344CB8AC3E}">
         <p14:creationId xmlns:p14="http://schemas.microsoft.com/office/powerpoint/2010/main" val="3483772906"/>
+      </p:ext>
+    </p:extLst>
+  </p:cSld>
+  <p:clrMapOvr>
+    <a:masterClrMapping/>
+  </p:clrMapOvr>
+</p:sld>
+</file>
+
+<file path=ppt/slides/slide2.xml><?xml version="1.0" encoding="utf-8"?>
+<p:sld xmlns:a="http://schemas.openxmlformats.org/drawingml/2006/main" xmlns:r="http://schemas.openxmlformats.org/officeDocument/2006/relationships" xmlns:p="http://schemas.openxmlformats.org/presentationml/2006/main">
+  <p:cSld>
+    <p:spTree>
+      <p:nvGrpSpPr>
+        <p:cNvPr id="1" name=""/>
+        <p:cNvGrpSpPr/>
+        <p:nvPr/>
+      </p:nvGrpSpPr>
+      <p:grpSpPr>
+        <a:xfrm>
+          <a:off x="0" y="0"/>
+          <a:ext cx="0" cy="0"/>
+          <a:chOff x="0" y="0"/>
+          <a:chExt cx="0" cy="0"/>
+        </a:xfrm>
+      </p:grpSpPr>
+      <p:sp>
+        <p:nvSpPr>
+          <p:cNvPr id="2" name="TextBox 1">
+            <a:extLst>
+              <a:ext uri="{FF2B5EF4-FFF2-40B4-BE49-F238E27FC236}">
+                <a16:creationId xmlns:a16="http://schemas.microsoft.com/office/drawing/2014/main" id="{EF7D9F39-8197-081B-A549-CF574EBC258C}"/>
+              </a:ext>
+            </a:extLst>
+          </p:cNvPr>
+          <p:cNvSpPr txBox="1"/>
+          <p:nvPr/>
+        </p:nvSpPr>
+        <p:spPr>
+          <a:xfrm>
+            <a:off x="892629" y="1317171"/>
+            <a:ext cx="2301143" cy="369332"/>
+          </a:xfrm>
+          <a:prstGeom prst="rect">
+            <a:avLst/>
+          </a:prstGeom>
+          <a:noFill/>
+        </p:spPr>
+        <p:txBody>
+          <a:bodyPr wrap="none" rtlCol="0">
+            <a:spAutoFit/>
+          </a:bodyPr>
+          <a:lstStyle/>
+          <a:p>
+            <a:r>
+              <a:rPr lang="en-US" dirty="0"/>
+              <a:t>Physical Component </a:t>
+            </a:r>
+          </a:p>
+        </p:txBody>
+      </p:sp>
+      <p:sp>
+        <p:nvSpPr>
+          <p:cNvPr id="3" name="TextBox 2">
+            <a:extLst>
+              <a:ext uri="{FF2B5EF4-FFF2-40B4-BE49-F238E27FC236}">
+                <a16:creationId xmlns:a16="http://schemas.microsoft.com/office/drawing/2014/main" id="{AFF3D70F-8E2B-BE77-AD79-2CB76195B515}"/>
+              </a:ext>
+            </a:extLst>
+          </p:cNvPr>
+          <p:cNvSpPr txBox="1"/>
+          <p:nvPr/>
+        </p:nvSpPr>
+        <p:spPr>
+          <a:xfrm>
+            <a:off x="1399763" y="3386239"/>
+            <a:ext cx="2409890" cy="369332"/>
+          </a:xfrm>
+          <a:prstGeom prst="rect">
+            <a:avLst/>
+          </a:prstGeom>
+          <a:noFill/>
+        </p:spPr>
+        <p:txBody>
+          <a:bodyPr wrap="none" rtlCol="0">
+            <a:spAutoFit/>
+          </a:bodyPr>
+          <a:lstStyle/>
+          <a:p>
+            <a:r>
+              <a:rPr lang="en-US" dirty="0"/>
+              <a:t>Electrical Component </a:t>
+            </a:r>
+          </a:p>
+        </p:txBody>
+      </p:sp>
+      <p:sp>
+        <p:nvSpPr>
+          <p:cNvPr id="5" name="TextBox 4">
+            <a:extLst>
+              <a:ext uri="{FF2B5EF4-FFF2-40B4-BE49-F238E27FC236}">
+                <a16:creationId xmlns:a16="http://schemas.microsoft.com/office/drawing/2014/main" id="{3A07B290-F50E-A476-FBB5-74C5DBE41A66}"/>
+              </a:ext>
+            </a:extLst>
+          </p:cNvPr>
+          <p:cNvSpPr txBox="1"/>
+          <p:nvPr/>
+        </p:nvSpPr>
+        <p:spPr>
+          <a:xfrm>
+            <a:off x="4634633" y="2220685"/>
+            <a:ext cx="2136932" cy="369332"/>
+          </a:xfrm>
+          <a:prstGeom prst="rect">
+            <a:avLst/>
+          </a:prstGeom>
+          <a:noFill/>
+        </p:spPr>
+        <p:txBody>
+          <a:bodyPr wrap="none" rtlCol="0">
+            <a:spAutoFit/>
+          </a:bodyPr>
+          <a:lstStyle/>
+          <a:p>
+            <a:r>
+              <a:rPr lang="en-US" dirty="0"/>
+              <a:t>Energy Component </a:t>
+            </a:r>
+          </a:p>
+        </p:txBody>
+      </p:sp>
+      <p:sp>
+        <p:nvSpPr>
+          <p:cNvPr id="6" name="TextBox 5">
+            <a:extLst>
+              <a:ext uri="{FF2B5EF4-FFF2-40B4-BE49-F238E27FC236}">
+                <a16:creationId xmlns:a16="http://schemas.microsoft.com/office/drawing/2014/main" id="{C045F551-7F0D-97A7-62E2-92025C8120AE}"/>
+              </a:ext>
+            </a:extLst>
+          </p:cNvPr>
+          <p:cNvSpPr txBox="1"/>
+          <p:nvPr/>
+        </p:nvSpPr>
+        <p:spPr>
+          <a:xfrm>
+            <a:off x="5127172" y="685800"/>
+            <a:ext cx="2192523" cy="369332"/>
+          </a:xfrm>
+          <a:prstGeom prst="rect">
+            <a:avLst/>
+          </a:prstGeom>
+          <a:noFill/>
+        </p:spPr>
+        <p:txBody>
+          <a:bodyPr wrap="none" rtlCol="0">
+            <a:spAutoFit/>
+          </a:bodyPr>
+          <a:lstStyle/>
+          <a:p>
+            <a:r>
+              <a:rPr lang="en-US" dirty="0"/>
+              <a:t>Operational Context</a:t>
+            </a:r>
+          </a:p>
+        </p:txBody>
+      </p:sp>
+      <p:cxnSp>
+        <p:nvCxnSpPr>
+          <p:cNvPr id="8" name="Straight Arrow Connector 7">
+            <a:extLst>
+              <a:ext uri="{FF2B5EF4-FFF2-40B4-BE49-F238E27FC236}">
+                <a16:creationId xmlns:a16="http://schemas.microsoft.com/office/drawing/2014/main" id="{1090F48E-BD16-A172-3C27-C42EAC36676E}"/>
+              </a:ext>
+            </a:extLst>
+          </p:cNvPr>
+          <p:cNvCxnSpPr>
+            <a:stCxn id="2" idx="2"/>
+            <a:endCxn id="3" idx="0"/>
+          </p:cNvCxnSpPr>
+          <p:nvPr/>
+        </p:nvCxnSpPr>
+        <p:spPr>
+          <a:xfrm>
+            <a:off x="2043201" y="1686503"/>
+            <a:ext cx="561507" cy="1699736"/>
+          </a:xfrm>
+          <a:prstGeom prst="straightConnector1">
+            <a:avLst/>
+          </a:prstGeom>
+          <a:ln>
+            <a:tailEnd type="triangle"/>
+          </a:ln>
+        </p:spPr>
+        <p:style>
+          <a:lnRef idx="2">
+            <a:schemeClr val="accent1"/>
+          </a:lnRef>
+          <a:fillRef idx="0">
+            <a:schemeClr val="accent1"/>
+          </a:fillRef>
+          <a:effectRef idx="1">
+            <a:schemeClr val="accent1"/>
+          </a:effectRef>
+          <a:fontRef idx="minor">
+            <a:schemeClr val="tx1"/>
+          </a:fontRef>
+        </p:style>
+      </p:cxnSp>
+      <p:cxnSp>
+        <p:nvCxnSpPr>
+          <p:cNvPr id="9" name="Straight Arrow Connector 8">
+            <a:extLst>
+              <a:ext uri="{FF2B5EF4-FFF2-40B4-BE49-F238E27FC236}">
+                <a16:creationId xmlns:a16="http://schemas.microsoft.com/office/drawing/2014/main" id="{512F751C-0897-B619-2914-6648D98DA764}"/>
+              </a:ext>
+            </a:extLst>
+          </p:cNvPr>
+          <p:cNvCxnSpPr>
+            <a:cxnSpLocks/>
+            <a:stCxn id="2" idx="3"/>
+            <a:endCxn id="5" idx="0"/>
+          </p:cNvCxnSpPr>
+          <p:nvPr/>
+        </p:nvCxnSpPr>
+        <p:spPr>
+          <a:xfrm>
+            <a:off x="3193772" y="1501837"/>
+            <a:ext cx="2509327" cy="718848"/>
+          </a:xfrm>
+          <a:prstGeom prst="straightConnector1">
+            <a:avLst/>
+          </a:prstGeom>
+          <a:ln>
+            <a:tailEnd type="triangle"/>
+          </a:ln>
+        </p:spPr>
+        <p:style>
+          <a:lnRef idx="2">
+            <a:schemeClr val="accent1"/>
+          </a:lnRef>
+          <a:fillRef idx="0">
+            <a:schemeClr val="accent1"/>
+          </a:fillRef>
+          <a:effectRef idx="1">
+            <a:schemeClr val="accent1"/>
+          </a:effectRef>
+          <a:fontRef idx="minor">
+            <a:schemeClr val="tx1"/>
+          </a:fontRef>
+        </p:style>
+      </p:cxnSp>
+      <p:cxnSp>
+        <p:nvCxnSpPr>
+          <p:cNvPr id="13" name="Straight Arrow Connector 12">
+            <a:extLst>
+              <a:ext uri="{FF2B5EF4-FFF2-40B4-BE49-F238E27FC236}">
+                <a16:creationId xmlns:a16="http://schemas.microsoft.com/office/drawing/2014/main" id="{BB8A8231-8D93-EF09-157F-9734825C4479}"/>
+              </a:ext>
+            </a:extLst>
+          </p:cNvPr>
+          <p:cNvCxnSpPr>
+            <a:cxnSpLocks/>
+            <a:stCxn id="3" idx="3"/>
+            <a:endCxn id="5" idx="2"/>
+          </p:cNvCxnSpPr>
+          <p:nvPr/>
+        </p:nvCxnSpPr>
+        <p:spPr>
+          <a:xfrm flipV="1">
+            <a:off x="3809653" y="2590017"/>
+            <a:ext cx="1893446" cy="980888"/>
+          </a:xfrm>
+          <a:prstGeom prst="straightConnector1">
+            <a:avLst/>
+          </a:prstGeom>
+          <a:ln>
+            <a:tailEnd type="triangle"/>
+          </a:ln>
+        </p:spPr>
+        <p:style>
+          <a:lnRef idx="2">
+            <a:schemeClr val="accent1"/>
+          </a:lnRef>
+          <a:fillRef idx="0">
+            <a:schemeClr val="accent1"/>
+          </a:fillRef>
+          <a:effectRef idx="1">
+            <a:schemeClr val="accent1"/>
+          </a:effectRef>
+          <a:fontRef idx="minor">
+            <a:schemeClr val="tx1"/>
+          </a:fontRef>
+        </p:style>
+      </p:cxnSp>
+      <p:cxnSp>
+        <p:nvCxnSpPr>
+          <p:cNvPr id="16" name="Straight Arrow Connector 15">
+            <a:extLst>
+              <a:ext uri="{FF2B5EF4-FFF2-40B4-BE49-F238E27FC236}">
+                <a16:creationId xmlns:a16="http://schemas.microsoft.com/office/drawing/2014/main" id="{C7AAC402-0D82-7543-F0D6-2EF8D43AF816}"/>
+              </a:ext>
+            </a:extLst>
+          </p:cNvPr>
+          <p:cNvCxnSpPr>
+            <a:cxnSpLocks/>
+            <a:stCxn id="6" idx="1"/>
+            <a:endCxn id="2" idx="0"/>
+          </p:cNvCxnSpPr>
+          <p:nvPr/>
+        </p:nvCxnSpPr>
+        <p:spPr>
+          <a:xfrm flipH="1">
+            <a:off x="2043201" y="870466"/>
+            <a:ext cx="3083971" cy="446705"/>
+          </a:xfrm>
+          <a:prstGeom prst="straightConnector1">
+            <a:avLst/>
+          </a:prstGeom>
+          <a:ln>
+            <a:tailEnd type="triangle"/>
+          </a:ln>
+        </p:spPr>
+        <p:style>
+          <a:lnRef idx="2">
+            <a:schemeClr val="accent1"/>
+          </a:lnRef>
+          <a:fillRef idx="0">
+            <a:schemeClr val="accent1"/>
+          </a:fillRef>
+          <a:effectRef idx="1">
+            <a:schemeClr val="accent1"/>
+          </a:effectRef>
+          <a:fontRef idx="minor">
+            <a:schemeClr val="tx1"/>
+          </a:fontRef>
+        </p:style>
+      </p:cxnSp>
+      <p:cxnSp>
+        <p:nvCxnSpPr>
+          <p:cNvPr id="19" name="Straight Arrow Connector 18">
+            <a:extLst>
+              <a:ext uri="{FF2B5EF4-FFF2-40B4-BE49-F238E27FC236}">
+                <a16:creationId xmlns:a16="http://schemas.microsoft.com/office/drawing/2014/main" id="{47A108AB-20BA-8BAC-70B9-68B65053FB37}"/>
+              </a:ext>
+            </a:extLst>
+          </p:cNvPr>
+          <p:cNvCxnSpPr>
+            <a:cxnSpLocks/>
+            <a:stCxn id="6" idx="2"/>
+            <a:endCxn id="5" idx="0"/>
+          </p:cNvCxnSpPr>
+          <p:nvPr/>
+        </p:nvCxnSpPr>
+        <p:spPr>
+          <a:xfrm flipH="1">
+            <a:off x="5703099" y="1055132"/>
+            <a:ext cx="520335" cy="1165553"/>
+          </a:xfrm>
+          <a:prstGeom prst="straightConnector1">
+            <a:avLst/>
+          </a:prstGeom>
+          <a:ln>
+            <a:tailEnd type="triangle"/>
+          </a:ln>
+        </p:spPr>
+        <p:style>
+          <a:lnRef idx="2">
+            <a:schemeClr val="accent1"/>
+          </a:lnRef>
+          <a:fillRef idx="0">
+            <a:schemeClr val="accent1"/>
+          </a:fillRef>
+          <a:effectRef idx="1">
+            <a:schemeClr val="accent1"/>
+          </a:effectRef>
+          <a:fontRef idx="minor">
+            <a:schemeClr val="tx1"/>
+          </a:fontRef>
+        </p:style>
+      </p:cxnSp>
+      <p:cxnSp>
+        <p:nvCxnSpPr>
+          <p:cNvPr id="22" name="Straight Arrow Connector 21">
+            <a:extLst>
+              <a:ext uri="{FF2B5EF4-FFF2-40B4-BE49-F238E27FC236}">
+                <a16:creationId xmlns:a16="http://schemas.microsoft.com/office/drawing/2014/main" id="{27DC8405-AE5C-434E-AF3F-8EE000F1557A}"/>
+              </a:ext>
+            </a:extLst>
+          </p:cNvPr>
+          <p:cNvCxnSpPr>
+            <a:cxnSpLocks/>
+            <a:stCxn id="6" idx="2"/>
+            <a:endCxn id="3" idx="0"/>
+          </p:cNvCxnSpPr>
+          <p:nvPr/>
+        </p:nvCxnSpPr>
+        <p:spPr>
+          <a:xfrm flipH="1">
+            <a:off x="2604708" y="1055132"/>
+            <a:ext cx="3618726" cy="2331107"/>
+          </a:xfrm>
+          <a:prstGeom prst="straightConnector1">
+            <a:avLst/>
+          </a:prstGeom>
+          <a:ln>
+            <a:tailEnd type="triangle"/>
+          </a:ln>
+        </p:spPr>
+        <p:style>
+          <a:lnRef idx="2">
+            <a:schemeClr val="accent1"/>
+          </a:lnRef>
+          <a:fillRef idx="0">
+            <a:schemeClr val="accent1"/>
+          </a:fillRef>
+          <a:effectRef idx="1">
+            <a:schemeClr val="accent1"/>
+          </a:effectRef>
+          <a:fontRef idx="minor">
+            <a:schemeClr val="tx1"/>
+          </a:fontRef>
+        </p:style>
+      </p:cxnSp>
+      <p:sp>
+        <p:nvSpPr>
+          <p:cNvPr id="52" name="TextBox 51">
+            <a:extLst>
+              <a:ext uri="{FF2B5EF4-FFF2-40B4-BE49-F238E27FC236}">
+                <a16:creationId xmlns:a16="http://schemas.microsoft.com/office/drawing/2014/main" id="{A5511CD3-68DE-B896-00E1-3554E50BBE3C}"/>
+              </a:ext>
+            </a:extLst>
+          </p:cNvPr>
+          <p:cNvSpPr txBox="1"/>
+          <p:nvPr/>
+        </p:nvSpPr>
+        <p:spPr>
+          <a:xfrm>
+            <a:off x="105513" y="4716195"/>
+            <a:ext cx="2475614" cy="923330"/>
+          </a:xfrm>
+          <a:prstGeom prst="rect">
+            <a:avLst/>
+          </a:prstGeom>
+          <a:noFill/>
+        </p:spPr>
+        <p:txBody>
+          <a:bodyPr wrap="none" rtlCol="0">
+            <a:spAutoFit/>
+          </a:bodyPr>
+          <a:lstStyle/>
+          <a:p>
+            <a:r>
+              <a:rPr lang="en-US" dirty="0"/>
+              <a:t>Electrical Component: </a:t>
+            </a:r>
+          </a:p>
+          <a:p>
+            <a:pPr marL="285750" indent="-285750">
+              <a:buFont typeface="Arial" panose="020B0604020202020204" pitchFamily="34" charset="0"/>
+              <a:buChar char="•"/>
+            </a:pPr>
+            <a:r>
+              <a:rPr lang="en-US" dirty="0">
+                <a:solidFill>
+                  <a:schemeClr val="accent6"/>
+                </a:solidFill>
+              </a:rPr>
+              <a:t>Status </a:t>
+            </a:r>
+          </a:p>
+          <a:p>
+            <a:endParaRPr lang="en-US" dirty="0"/>
+          </a:p>
+        </p:txBody>
+      </p:sp>
+      <p:sp>
+        <p:nvSpPr>
+          <p:cNvPr id="53" name="TextBox 52">
+            <a:extLst>
+              <a:ext uri="{FF2B5EF4-FFF2-40B4-BE49-F238E27FC236}">
+                <a16:creationId xmlns:a16="http://schemas.microsoft.com/office/drawing/2014/main" id="{7E6AD107-AF82-DADA-B9E0-A209B2627AB2}"/>
+              </a:ext>
+            </a:extLst>
+          </p:cNvPr>
+          <p:cNvSpPr txBox="1"/>
+          <p:nvPr/>
+        </p:nvSpPr>
+        <p:spPr>
+          <a:xfrm>
+            <a:off x="3335844" y="4716195"/>
+            <a:ext cx="2090444" cy="1754326"/>
+          </a:xfrm>
+          <a:prstGeom prst="rect">
+            <a:avLst/>
+          </a:prstGeom>
+          <a:noFill/>
+        </p:spPr>
+        <p:txBody>
+          <a:bodyPr wrap="none" rtlCol="0">
+            <a:spAutoFit/>
+          </a:bodyPr>
+          <a:lstStyle/>
+          <a:p>
+            <a:r>
+              <a:rPr lang="en-US" dirty="0"/>
+              <a:t>Energy Component</a:t>
+            </a:r>
+          </a:p>
+          <a:p>
+            <a:pPr marL="285750" indent="-285750">
+              <a:buFont typeface="Arial" panose="020B0604020202020204" pitchFamily="34" charset="0"/>
+              <a:buChar char="•"/>
+            </a:pPr>
+            <a:r>
+              <a:rPr lang="en-US" dirty="0">
+                <a:solidFill>
+                  <a:schemeClr val="accent6"/>
+                </a:solidFill>
+              </a:rPr>
+              <a:t>Initial Charge</a:t>
+            </a:r>
+          </a:p>
+          <a:p>
+            <a:pPr marL="285750" indent="-285750">
+              <a:buFont typeface="Arial" panose="020B0604020202020204" pitchFamily="34" charset="0"/>
+              <a:buChar char="•"/>
+            </a:pPr>
+            <a:r>
+              <a:rPr lang="en-US" dirty="0"/>
+              <a:t>Charge Rate</a:t>
+            </a:r>
+          </a:p>
+          <a:p>
+            <a:pPr marL="285750" indent="-285750">
+              <a:buFont typeface="Arial" panose="020B0604020202020204" pitchFamily="34" charset="0"/>
+              <a:buChar char="•"/>
+            </a:pPr>
+            <a:r>
+              <a:rPr lang="en-US" dirty="0">
+                <a:solidFill>
+                  <a:schemeClr val="accent6"/>
+                </a:solidFill>
+              </a:rPr>
+              <a:t>Discharge Rate </a:t>
+            </a:r>
+          </a:p>
+          <a:p>
+            <a:endParaRPr lang="en-US" dirty="0"/>
+          </a:p>
+          <a:p>
+            <a:endParaRPr lang="en-US" dirty="0"/>
+          </a:p>
+        </p:txBody>
+      </p:sp>
+      <p:sp>
+        <p:nvSpPr>
+          <p:cNvPr id="56" name="TextBox 55">
+            <a:extLst>
+              <a:ext uri="{FF2B5EF4-FFF2-40B4-BE49-F238E27FC236}">
+                <a16:creationId xmlns:a16="http://schemas.microsoft.com/office/drawing/2014/main" id="{3ABE2E0C-2E02-B485-5A84-D11E8BA711A8}"/>
+              </a:ext>
+            </a:extLst>
+          </p:cNvPr>
+          <p:cNvSpPr txBox="1"/>
+          <p:nvPr/>
+        </p:nvSpPr>
+        <p:spPr>
+          <a:xfrm>
+            <a:off x="6732709" y="4716195"/>
+            <a:ext cx="2192523" cy="1477328"/>
+          </a:xfrm>
+          <a:prstGeom prst="rect">
+            <a:avLst/>
+          </a:prstGeom>
+          <a:noFill/>
+        </p:spPr>
+        <p:txBody>
+          <a:bodyPr wrap="none" rtlCol="0">
+            <a:spAutoFit/>
+          </a:bodyPr>
+          <a:lstStyle/>
+          <a:p>
+            <a:r>
+              <a:rPr lang="en-US" dirty="0"/>
+              <a:t>Operational Context</a:t>
+            </a:r>
+          </a:p>
+          <a:p>
+            <a:pPr marL="285750" indent="-285750">
+              <a:buFont typeface="Arial" panose="020B0604020202020204" pitchFamily="34" charset="0"/>
+              <a:buChar char="•"/>
+            </a:pPr>
+            <a:r>
+              <a:rPr lang="en-US" dirty="0"/>
+              <a:t>Initial Charge</a:t>
+            </a:r>
+          </a:p>
+          <a:p>
+            <a:pPr marL="285750" indent="-285750">
+              <a:buFont typeface="Arial" panose="020B0604020202020204" pitchFamily="34" charset="0"/>
+              <a:buChar char="•"/>
+            </a:pPr>
+            <a:r>
+              <a:rPr lang="en-US" dirty="0">
+                <a:solidFill>
+                  <a:schemeClr val="bg1">
+                    <a:lumMod val="85000"/>
+                  </a:schemeClr>
+                </a:solidFill>
+              </a:rPr>
+              <a:t>Charge Rate</a:t>
+            </a:r>
+          </a:p>
+          <a:p>
+            <a:pPr marL="285750" indent="-285750">
+              <a:buFont typeface="Arial" panose="020B0604020202020204" pitchFamily="34" charset="0"/>
+              <a:buChar char="•"/>
+            </a:pPr>
+            <a:r>
+              <a:rPr lang="en-US" dirty="0"/>
+              <a:t>Discharge Rate </a:t>
+            </a:r>
+          </a:p>
+          <a:p>
+            <a:endParaRPr lang="en-US" dirty="0"/>
+          </a:p>
+        </p:txBody>
+      </p:sp>
+      <p:sp>
+        <p:nvSpPr>
+          <p:cNvPr id="57" name="TextBox 56">
+            <a:extLst>
+              <a:ext uri="{FF2B5EF4-FFF2-40B4-BE49-F238E27FC236}">
+                <a16:creationId xmlns:a16="http://schemas.microsoft.com/office/drawing/2014/main" id="{86F31D8E-88A5-2B66-A9CC-6A525B193ECD}"/>
+              </a:ext>
+            </a:extLst>
+          </p:cNvPr>
+          <p:cNvSpPr txBox="1"/>
+          <p:nvPr/>
+        </p:nvSpPr>
+        <p:spPr>
+          <a:xfrm>
+            <a:off x="11353801" y="6368535"/>
+            <a:ext cx="633507" cy="369332"/>
+          </a:xfrm>
+          <a:prstGeom prst="rect">
+            <a:avLst/>
+          </a:prstGeom>
+          <a:noFill/>
+        </p:spPr>
+        <p:txBody>
+          <a:bodyPr wrap="none" rtlCol="0">
+            <a:spAutoFit/>
+          </a:bodyPr>
+          <a:lstStyle/>
+          <a:p>
+            <a:r>
+              <a:rPr lang="en-US" dirty="0"/>
+              <a:t>8/11</a:t>
+            </a:r>
+          </a:p>
+        </p:txBody>
+      </p:sp>
+    </p:spTree>
+    <p:extLst>
+      <p:ext uri="{BB962C8B-B14F-4D97-AF65-F5344CB8AC3E}">
+        <p14:creationId xmlns:p14="http://schemas.microsoft.com/office/powerpoint/2010/main" val="398408516"/>
+      </p:ext>
+    </p:extLst>
+  </p:cSld>
+  <p:clrMapOvr>
+    <a:masterClrMapping/>
+  </p:clrMapOvr>
+</p:sld>
+</file>
+
+<file path=ppt/slides/slide3.xml><?xml version="1.0" encoding="utf-8"?>
+<p:sld xmlns:a="http://schemas.openxmlformats.org/drawingml/2006/main" xmlns:r="http://schemas.openxmlformats.org/officeDocument/2006/relationships" xmlns:p="http://schemas.openxmlformats.org/presentationml/2006/main">
+  <p:cSld>
+    <p:spTree>
+      <p:nvGrpSpPr>
+        <p:cNvPr id="1" name=""/>
+        <p:cNvGrpSpPr/>
+        <p:nvPr/>
+      </p:nvGrpSpPr>
+      <p:grpSpPr>
+        <a:xfrm>
+          <a:off x="0" y="0"/>
+          <a:ext cx="0" cy="0"/>
+          <a:chOff x="0" y="0"/>
+          <a:chExt cx="0" cy="0"/>
+        </a:xfrm>
+      </p:grpSpPr>
+      <mc:AlternateContent xmlns:mc="http://schemas.openxmlformats.org/markup-compatibility/2006">
+        <mc:Choice xmlns:a14="http://schemas.microsoft.com/office/drawing/2010/main" Requires="a14">
+          <p:sp>
+            <p:nvSpPr>
+              <p:cNvPr id="5" name="Oval 4">
+                <a:extLst>
+                  <a:ext uri="{FF2B5EF4-FFF2-40B4-BE49-F238E27FC236}">
+                    <a16:creationId xmlns:a16="http://schemas.microsoft.com/office/drawing/2014/main" id="{56B47806-8DD3-D6EF-52BC-51985F431706}"/>
+                  </a:ext>
+                </a:extLst>
+              </p:cNvPr>
+              <p:cNvSpPr/>
+              <p:nvPr/>
+            </p:nvSpPr>
+            <p:spPr>
+              <a:xfrm>
+                <a:off x="7059735" y="3918857"/>
+                <a:ext cx="1475014" cy="1475014"/>
+              </a:xfrm>
+              <a:prstGeom prst="ellipse">
+                <a:avLst/>
+              </a:prstGeom>
+              <a:solidFill>
+                <a:schemeClr val="bg1">
+                  <a:lumMod val="85000"/>
+                </a:schemeClr>
+              </a:solidFill>
+            </p:spPr>
+            <p:style>
+              <a:lnRef idx="1">
+                <a:schemeClr val="dk1"/>
+              </a:lnRef>
+              <a:fillRef idx="2">
+                <a:schemeClr val="dk1"/>
+              </a:fillRef>
+              <a:effectRef idx="1">
+                <a:schemeClr val="dk1"/>
+              </a:effectRef>
+              <a:fontRef idx="minor">
+                <a:schemeClr val="dk1"/>
+              </a:fontRef>
+            </p:style>
+            <p:txBody>
+              <a:bodyPr rtlCol="0" anchor="ctr"/>
+              <a:lstStyle/>
+              <a:p>
+                <a:pPr algn="ctr"/>
+                <a14:m>
+                  <m:oMathPara xmlns:m="http://schemas.openxmlformats.org/officeDocument/2006/math">
+                    <m:oMathParaPr>
+                      <m:jc m:val="centerGroup"/>
+                    </m:oMathParaPr>
+                    <m:oMath xmlns:m="http://schemas.openxmlformats.org/officeDocument/2006/math">
+                      <m:r>
+                        <a:rPr lang="en-US" b="0" i="1" smtClean="0">
+                          <a:latin typeface="Cambria Math" panose="02040503050406030204" pitchFamily="18" charset="0"/>
+                        </a:rPr>
+                        <m:t>𝐵𝑎𝑡𝑡𝑒𝑟𝑦</m:t>
+                      </m:r>
+                    </m:oMath>
+                  </m:oMathPara>
+                </a14:m>
+                <a:endParaRPr lang="en-US" dirty="0"/>
+              </a:p>
+            </p:txBody>
+          </p:sp>
+        </mc:Choice>
+        <mc:Fallback>
+          <p:sp>
+            <p:nvSpPr>
+              <p:cNvPr id="5" name="Oval 4">
+                <a:extLst>
+                  <a:ext uri="{FF2B5EF4-FFF2-40B4-BE49-F238E27FC236}">
+                    <a16:creationId xmlns:a16="http://schemas.microsoft.com/office/drawing/2014/main" id="{56B47806-8DD3-D6EF-52BC-51985F431706}"/>
+                  </a:ext>
+                </a:extLst>
+              </p:cNvPr>
+              <p:cNvSpPr>
+                <a:spLocks noRot="1" noChangeAspect="1" noMove="1" noResize="1" noEditPoints="1" noAdjustHandles="1" noChangeArrowheads="1" noChangeShapeType="1" noTextEdit="1"/>
+              </p:cNvSpPr>
+              <p:nvPr/>
+            </p:nvSpPr>
+            <p:spPr>
+              <a:xfrm>
+                <a:off x="7059735" y="3918857"/>
+                <a:ext cx="1475014" cy="1475014"/>
+              </a:xfrm>
+              <a:prstGeom prst="ellipse">
+                <a:avLst/>
+              </a:prstGeom>
+              <a:blipFill>
+                <a:blip r:embed="rId2"/>
+                <a:stretch>
+                  <a:fillRect/>
+                </a:stretch>
+              </a:blipFill>
+            </p:spPr>
+            <p:txBody>
+              <a:bodyPr/>
+              <a:lstStyle/>
+              <a:p>
+                <a:r>
+                  <a:rPr lang="en-US">
+                    <a:noFill/>
+                  </a:rPr>
+                  <a:t> </a:t>
+                </a:r>
+              </a:p>
+            </p:txBody>
+          </p:sp>
+        </mc:Fallback>
+      </mc:AlternateContent>
+      <mc:AlternateContent xmlns:mc="http://schemas.openxmlformats.org/markup-compatibility/2006">
+        <mc:Choice xmlns:a14="http://schemas.microsoft.com/office/drawing/2010/main" Requires="a14">
+          <p:sp>
+            <p:nvSpPr>
+              <p:cNvPr id="6" name="Oval 5">
+                <a:extLst>
+                  <a:ext uri="{FF2B5EF4-FFF2-40B4-BE49-F238E27FC236}">
+                    <a16:creationId xmlns:a16="http://schemas.microsoft.com/office/drawing/2014/main" id="{C602610C-48C6-9A7F-6764-3DF54170D940}"/>
+                  </a:ext>
+                </a:extLst>
+              </p:cNvPr>
+              <p:cNvSpPr/>
+              <p:nvPr/>
+            </p:nvSpPr>
+            <p:spPr>
+              <a:xfrm>
+                <a:off x="9034843" y="2151101"/>
+                <a:ext cx="1475014" cy="1475014"/>
+              </a:xfrm>
+              <a:prstGeom prst="ellipse">
+                <a:avLst/>
+              </a:prstGeom>
+              <a:solidFill>
+                <a:srgbClr val="9BCCF7"/>
+              </a:solidFill>
+            </p:spPr>
+            <p:style>
+              <a:lnRef idx="1">
+                <a:schemeClr val="dk1"/>
+              </a:lnRef>
+              <a:fillRef idx="2">
+                <a:schemeClr val="dk1"/>
+              </a:fillRef>
+              <a:effectRef idx="1">
+                <a:schemeClr val="dk1"/>
+              </a:effectRef>
+              <a:fontRef idx="minor">
+                <a:schemeClr val="dk1"/>
+              </a:fontRef>
+            </p:style>
+            <p:txBody>
+              <a:bodyPr rtlCol="0" anchor="ctr"/>
+              <a:lstStyle/>
+              <a:p>
+                <a:pPr algn="ctr"/>
+                <a14:m>
+                  <m:oMathPara xmlns:m="http://schemas.openxmlformats.org/officeDocument/2006/math">
+                    <m:oMathParaPr>
+                      <m:jc m:val="centerGroup"/>
+                    </m:oMathParaPr>
+                    <m:oMath xmlns:m="http://schemas.openxmlformats.org/officeDocument/2006/math">
+                      <m:sSub>
+                        <m:sSubPr>
+                          <m:ctrlPr>
+                            <a:rPr lang="en-US" b="0" i="1" smtClean="0">
+                              <a:latin typeface="Cambria Math" panose="02040503050406030204" pitchFamily="18" charset="0"/>
+                            </a:rPr>
+                          </m:ctrlPr>
+                        </m:sSubPr>
+                        <m:e>
+                          <m:r>
+                            <a:rPr lang="en-US" b="0" i="1" smtClean="0">
+                              <a:latin typeface="Cambria Math" panose="02040503050406030204" pitchFamily="18" charset="0"/>
+                            </a:rPr>
+                            <m:t>𝐹</m:t>
+                          </m:r>
+                        </m:e>
+                        <m:sub>
+                          <m:eqArr>
+                            <m:eqArrPr>
+                              <m:ctrlPr>
+                                <a:rPr lang="en-US" b="0" i="1" smtClean="0">
+                                  <a:latin typeface="Cambria Math" panose="02040503050406030204" pitchFamily="18" charset="0"/>
+                                </a:rPr>
+                              </m:ctrlPr>
+                            </m:eqArrPr>
+                            <m:e>
+                              <m:r>
+                                <a:rPr lang="en-US" b="0" i="1" smtClean="0">
+                                  <a:latin typeface="Cambria Math" panose="02040503050406030204" pitchFamily="18" charset="0"/>
+                                </a:rPr>
+                                <m:t>𝑝𝑟𝑜𝑣𝑖𝑑𝑒𝑠</m:t>
+                              </m:r>
+                              <m:r>
+                                <a:rPr lang="en-US" b="0" i="1" smtClean="0">
+                                  <a:latin typeface="Cambria Math" panose="02040503050406030204" pitchFamily="18" charset="0"/>
+                                </a:rPr>
+                                <m:t> </m:t>
+                              </m:r>
+                            </m:e>
+                            <m:e>
+                              <m:r>
+                                <a:rPr lang="en-US" b="0" i="1" smtClean="0">
+                                  <a:latin typeface="Cambria Math" panose="02040503050406030204" pitchFamily="18" charset="0"/>
+                                </a:rPr>
+                                <m:t>𝑐h𝑎𝑟𝑔𝑒</m:t>
+                              </m:r>
+                            </m:e>
+                          </m:eqArr>
+                        </m:sub>
+                      </m:sSub>
+                    </m:oMath>
+                  </m:oMathPara>
+                </a14:m>
+                <a:endParaRPr lang="en-US" dirty="0"/>
+              </a:p>
+            </p:txBody>
+          </p:sp>
+        </mc:Choice>
+        <mc:Fallback>
+          <p:sp>
+            <p:nvSpPr>
+              <p:cNvPr id="6" name="Oval 5">
+                <a:extLst>
+                  <a:ext uri="{FF2B5EF4-FFF2-40B4-BE49-F238E27FC236}">
+                    <a16:creationId xmlns:a16="http://schemas.microsoft.com/office/drawing/2014/main" id="{C602610C-48C6-9A7F-6764-3DF54170D940}"/>
+                  </a:ext>
+                </a:extLst>
+              </p:cNvPr>
+              <p:cNvSpPr>
+                <a:spLocks noRot="1" noChangeAspect="1" noMove="1" noResize="1" noEditPoints="1" noAdjustHandles="1" noChangeArrowheads="1" noChangeShapeType="1" noTextEdit="1"/>
+              </p:cNvSpPr>
+              <p:nvPr/>
+            </p:nvSpPr>
+            <p:spPr>
+              <a:xfrm>
+                <a:off x="9034843" y="2151101"/>
+                <a:ext cx="1475014" cy="1475014"/>
+              </a:xfrm>
+              <a:prstGeom prst="ellipse">
+                <a:avLst/>
+              </a:prstGeom>
+              <a:blipFill>
+                <a:blip r:embed="rId3"/>
+                <a:stretch>
+                  <a:fillRect/>
+                </a:stretch>
+              </a:blipFill>
+            </p:spPr>
+            <p:txBody>
+              <a:bodyPr/>
+              <a:lstStyle/>
+              <a:p>
+                <a:r>
+                  <a:rPr lang="en-US">
+                    <a:noFill/>
+                  </a:rPr>
+                  <a:t> </a:t>
+                </a:r>
+              </a:p>
+            </p:txBody>
+          </p:sp>
+        </mc:Fallback>
+      </mc:AlternateContent>
+      <mc:AlternateContent xmlns:mc="http://schemas.openxmlformats.org/markup-compatibility/2006">
+        <mc:Choice xmlns:a14="http://schemas.microsoft.com/office/drawing/2010/main" Requires="a14">
+          <p:sp>
+            <p:nvSpPr>
+              <p:cNvPr id="7" name="Oval 6">
+                <a:extLst>
+                  <a:ext uri="{FF2B5EF4-FFF2-40B4-BE49-F238E27FC236}">
+                    <a16:creationId xmlns:a16="http://schemas.microsoft.com/office/drawing/2014/main" id="{8B9EF884-8B3D-F4A9-6A30-CAC5D0667234}"/>
+                  </a:ext>
+                </a:extLst>
+              </p:cNvPr>
+              <p:cNvSpPr/>
+              <p:nvPr/>
+            </p:nvSpPr>
+            <p:spPr>
+              <a:xfrm>
+                <a:off x="4448435" y="3940237"/>
+                <a:ext cx="1475014" cy="1475014"/>
+              </a:xfrm>
+              <a:prstGeom prst="ellipse">
+                <a:avLst/>
+              </a:prstGeom>
+              <a:solidFill>
+                <a:srgbClr val="FFC000"/>
+              </a:solidFill>
+            </p:spPr>
+            <p:style>
+              <a:lnRef idx="1">
+                <a:schemeClr val="dk1"/>
+              </a:lnRef>
+              <a:fillRef idx="2">
+                <a:schemeClr val="dk1"/>
+              </a:fillRef>
+              <a:effectRef idx="1">
+                <a:schemeClr val="dk1"/>
+              </a:effectRef>
+              <a:fontRef idx="minor">
+                <a:schemeClr val="dk1"/>
+              </a:fontRef>
+            </p:style>
+            <p:txBody>
+              <a:bodyPr rtlCol="0" anchor="ctr"/>
+              <a:lstStyle/>
+              <a:p>
+                <a:pPr algn="ctr"/>
+                <a14:m>
+                  <m:oMathPara xmlns:m="http://schemas.openxmlformats.org/officeDocument/2006/math">
+                    <m:oMathParaPr>
+                      <m:jc m:val="centerGroup"/>
+                    </m:oMathParaPr>
+                    <m:oMath xmlns:m="http://schemas.openxmlformats.org/officeDocument/2006/math">
+                      <m:sSub>
+                        <m:sSubPr>
+                          <m:ctrlPr>
+                            <a:rPr lang="en-US" b="0" i="1" smtClean="0">
+                              <a:latin typeface="Cambria Math" panose="02040503050406030204" pitchFamily="18" charset="0"/>
+                            </a:rPr>
+                          </m:ctrlPr>
+                        </m:sSubPr>
+                        <m:e>
+                          <m:r>
+                            <a:rPr lang="en-US" b="0" i="1" smtClean="0">
+                              <a:latin typeface="Cambria Math" panose="02040503050406030204" pitchFamily="18" charset="0"/>
+                            </a:rPr>
+                            <m:t>𝐻</m:t>
+                          </m:r>
+                        </m:e>
+                        <m:sub>
+                          <m:r>
+                            <a:rPr lang="en-US" b="0" i="1" smtClean="0">
+                              <a:latin typeface="Cambria Math" panose="02040503050406030204" pitchFamily="18" charset="0"/>
+                            </a:rPr>
+                            <m:t>𝑏𝑎𝑡𝑡𝑒𝑟𝑦</m:t>
+                          </m:r>
+                        </m:sub>
+                      </m:sSub>
+                    </m:oMath>
+                  </m:oMathPara>
+                </a14:m>
+                <a:endParaRPr lang="en-US" dirty="0"/>
+              </a:p>
+            </p:txBody>
+          </p:sp>
+        </mc:Choice>
+        <mc:Fallback>
+          <p:sp>
+            <p:nvSpPr>
+              <p:cNvPr id="7" name="Oval 6">
+                <a:extLst>
+                  <a:ext uri="{FF2B5EF4-FFF2-40B4-BE49-F238E27FC236}">
+                    <a16:creationId xmlns:a16="http://schemas.microsoft.com/office/drawing/2014/main" id="{8B9EF884-8B3D-F4A9-6A30-CAC5D0667234}"/>
+                  </a:ext>
+                </a:extLst>
+              </p:cNvPr>
+              <p:cNvSpPr>
+                <a:spLocks noRot="1" noChangeAspect="1" noMove="1" noResize="1" noEditPoints="1" noAdjustHandles="1" noChangeArrowheads="1" noChangeShapeType="1" noTextEdit="1"/>
+              </p:cNvSpPr>
+              <p:nvPr/>
+            </p:nvSpPr>
+            <p:spPr>
+              <a:xfrm>
+                <a:off x="4448435" y="3940237"/>
+                <a:ext cx="1475014" cy="1475014"/>
+              </a:xfrm>
+              <a:prstGeom prst="ellipse">
+                <a:avLst/>
+              </a:prstGeom>
+              <a:blipFill>
+                <a:blip r:embed="rId4"/>
+                <a:stretch>
+                  <a:fillRect/>
+                </a:stretch>
+              </a:blipFill>
+            </p:spPr>
+            <p:txBody>
+              <a:bodyPr/>
+              <a:lstStyle/>
+              <a:p>
+                <a:r>
+                  <a:rPr lang="en-US">
+                    <a:noFill/>
+                  </a:rPr>
+                  <a:t> </a:t>
+                </a:r>
+              </a:p>
+            </p:txBody>
+          </p:sp>
+        </mc:Fallback>
+      </mc:AlternateContent>
+      <mc:AlternateContent xmlns:mc="http://schemas.openxmlformats.org/markup-compatibility/2006">
+        <mc:Choice xmlns:a14="http://schemas.microsoft.com/office/drawing/2010/main" Requires="a14">
+          <p:sp>
+            <p:nvSpPr>
+              <p:cNvPr id="8" name="Oval 7">
+                <a:extLst>
+                  <a:ext uri="{FF2B5EF4-FFF2-40B4-BE49-F238E27FC236}">
+                    <a16:creationId xmlns:a16="http://schemas.microsoft.com/office/drawing/2014/main" id="{BC029B68-B306-4DBE-1369-750AA06186EC}"/>
+                  </a:ext>
+                </a:extLst>
+              </p:cNvPr>
+              <p:cNvSpPr/>
+              <p:nvPr/>
+            </p:nvSpPr>
+            <p:spPr>
+              <a:xfrm>
+                <a:off x="8933528" y="5252217"/>
+                <a:ext cx="1475014" cy="1475014"/>
+              </a:xfrm>
+              <a:prstGeom prst="ellipse">
+                <a:avLst/>
+              </a:prstGeom>
+              <a:solidFill>
+                <a:srgbClr val="FFC000"/>
+              </a:solidFill>
+            </p:spPr>
+            <p:style>
+              <a:lnRef idx="1">
+                <a:schemeClr val="dk1"/>
+              </a:lnRef>
+              <a:fillRef idx="2">
+                <a:schemeClr val="dk1"/>
+              </a:fillRef>
+              <a:effectRef idx="1">
+                <a:schemeClr val="dk1"/>
+              </a:effectRef>
+              <a:fontRef idx="minor">
+                <a:schemeClr val="dk1"/>
+              </a:fontRef>
+            </p:style>
+            <p:txBody>
+              <a:bodyPr rtlCol="0" anchor="ctr"/>
+              <a:lstStyle/>
+              <a:p>
+                <a:pPr algn="ctr"/>
+                <a14:m>
+                  <m:oMathPara xmlns:m="http://schemas.openxmlformats.org/officeDocument/2006/math">
+                    <m:oMathParaPr>
+                      <m:jc m:val="centerGroup"/>
+                    </m:oMathParaPr>
+                    <m:oMath xmlns:m="http://schemas.openxmlformats.org/officeDocument/2006/math">
+                      <m:sSub>
+                        <m:sSubPr>
+                          <m:ctrlPr>
+                            <a:rPr lang="en-US" b="0" i="1" smtClean="0">
+                              <a:latin typeface="Cambria Math" panose="02040503050406030204" pitchFamily="18" charset="0"/>
+                            </a:rPr>
+                          </m:ctrlPr>
+                        </m:sSubPr>
+                        <m:e>
+                          <m:r>
+                            <a:rPr lang="en-US" b="0" i="1" smtClean="0">
+                              <a:latin typeface="Cambria Math" panose="02040503050406030204" pitchFamily="18" charset="0"/>
+                            </a:rPr>
+                            <m:t>𝐶</m:t>
+                          </m:r>
+                        </m:e>
+                        <m:sub>
+                          <m:r>
+                            <a:rPr lang="en-US" b="0" i="1" smtClean="0">
+                              <a:latin typeface="Cambria Math" panose="02040503050406030204" pitchFamily="18" charset="0"/>
+                            </a:rPr>
+                            <m:t>𝑏𝑎𝑡𝑡𝑒𝑟𝑦</m:t>
+                          </m:r>
+                        </m:sub>
+                      </m:sSub>
+                    </m:oMath>
+                  </m:oMathPara>
+                </a14:m>
+                <a:endParaRPr lang="en-US" dirty="0"/>
+              </a:p>
+            </p:txBody>
+          </p:sp>
+        </mc:Choice>
+        <mc:Fallback>
+          <p:sp>
+            <p:nvSpPr>
+              <p:cNvPr id="8" name="Oval 7">
+                <a:extLst>
+                  <a:ext uri="{FF2B5EF4-FFF2-40B4-BE49-F238E27FC236}">
+                    <a16:creationId xmlns:a16="http://schemas.microsoft.com/office/drawing/2014/main" id="{BC029B68-B306-4DBE-1369-750AA06186EC}"/>
+                  </a:ext>
+                </a:extLst>
+              </p:cNvPr>
+              <p:cNvSpPr>
+                <a:spLocks noRot="1" noChangeAspect="1" noMove="1" noResize="1" noEditPoints="1" noAdjustHandles="1" noChangeArrowheads="1" noChangeShapeType="1" noTextEdit="1"/>
+              </p:cNvSpPr>
+              <p:nvPr/>
+            </p:nvSpPr>
+            <p:spPr>
+              <a:xfrm>
+                <a:off x="8933528" y="5252217"/>
+                <a:ext cx="1475014" cy="1475014"/>
+              </a:xfrm>
+              <a:prstGeom prst="ellipse">
+                <a:avLst/>
+              </a:prstGeom>
+              <a:blipFill>
+                <a:blip r:embed="rId5"/>
+                <a:stretch>
+                  <a:fillRect/>
+                </a:stretch>
+              </a:blipFill>
+            </p:spPr>
+            <p:txBody>
+              <a:bodyPr/>
+              <a:lstStyle/>
+              <a:p>
+                <a:r>
+                  <a:rPr lang="en-US">
+                    <a:noFill/>
+                  </a:rPr>
+                  <a:t> </a:t>
+                </a:r>
+              </a:p>
+            </p:txBody>
+          </p:sp>
+        </mc:Fallback>
+      </mc:AlternateContent>
+      <p:cxnSp>
+        <p:nvCxnSpPr>
+          <p:cNvPr id="9" name="Straight Arrow Connector 8">
+            <a:extLst>
+              <a:ext uri="{FF2B5EF4-FFF2-40B4-BE49-F238E27FC236}">
+                <a16:creationId xmlns:a16="http://schemas.microsoft.com/office/drawing/2014/main" id="{83599C2D-7487-F199-EC96-17CF6E322C91}"/>
+              </a:ext>
+            </a:extLst>
+          </p:cNvPr>
+          <p:cNvCxnSpPr/>
+          <p:nvPr/>
+        </p:nvCxnSpPr>
+        <p:spPr>
+          <a:xfrm flipV="1">
+            <a:off x="8318738" y="3410104"/>
+            <a:ext cx="932116" cy="724764"/>
+          </a:xfrm>
+          <a:prstGeom prst="straightConnector1">
+            <a:avLst/>
+          </a:prstGeom>
+          <a:ln>
+            <a:tailEnd type="triangle"/>
+          </a:ln>
+        </p:spPr>
+        <p:style>
+          <a:lnRef idx="2">
+            <a:schemeClr val="dk1"/>
+          </a:lnRef>
+          <a:fillRef idx="0">
+            <a:schemeClr val="dk1"/>
+          </a:fillRef>
+          <a:effectRef idx="1">
+            <a:schemeClr val="dk1"/>
+          </a:effectRef>
+          <a:fontRef idx="minor">
+            <a:schemeClr val="tx1"/>
+          </a:fontRef>
+        </p:style>
+      </p:cxnSp>
+      <p:cxnSp>
+        <p:nvCxnSpPr>
+          <p:cNvPr id="10" name="Straight Arrow Connector 9">
+            <a:extLst>
+              <a:ext uri="{FF2B5EF4-FFF2-40B4-BE49-F238E27FC236}">
+                <a16:creationId xmlns:a16="http://schemas.microsoft.com/office/drawing/2014/main" id="{9444DF66-BB3C-BA03-3535-92191DACDB4B}"/>
+              </a:ext>
+            </a:extLst>
+          </p:cNvPr>
+          <p:cNvCxnSpPr>
+            <a:cxnSpLocks/>
+          </p:cNvCxnSpPr>
+          <p:nvPr/>
+        </p:nvCxnSpPr>
+        <p:spPr>
+          <a:xfrm flipH="1">
+            <a:off x="5923449" y="4656364"/>
+            <a:ext cx="1136286" cy="21380"/>
+          </a:xfrm>
+          <a:prstGeom prst="straightConnector1">
+            <a:avLst/>
+          </a:prstGeom>
+          <a:ln>
+            <a:tailEnd type="triangle"/>
+          </a:ln>
+        </p:spPr>
+        <p:style>
+          <a:lnRef idx="2">
+            <a:schemeClr val="dk1"/>
+          </a:lnRef>
+          <a:fillRef idx="0">
+            <a:schemeClr val="dk1"/>
+          </a:fillRef>
+          <a:effectRef idx="1">
+            <a:schemeClr val="dk1"/>
+          </a:effectRef>
+          <a:fontRef idx="minor">
+            <a:schemeClr val="tx1"/>
+          </a:fontRef>
+        </p:style>
+      </p:cxnSp>
+      <p:cxnSp>
+        <p:nvCxnSpPr>
+          <p:cNvPr id="11" name="Straight Arrow Connector 10">
+            <a:extLst>
+              <a:ext uri="{FF2B5EF4-FFF2-40B4-BE49-F238E27FC236}">
+                <a16:creationId xmlns:a16="http://schemas.microsoft.com/office/drawing/2014/main" id="{E52F613A-8543-3F7A-5276-8147085FA0AA}"/>
+              </a:ext>
+            </a:extLst>
+          </p:cNvPr>
+          <p:cNvCxnSpPr>
+            <a:cxnSpLocks/>
+          </p:cNvCxnSpPr>
+          <p:nvPr/>
+        </p:nvCxnSpPr>
+        <p:spPr>
+          <a:xfrm flipV="1">
+            <a:off x="5707438" y="2888608"/>
+            <a:ext cx="3327405" cy="1267640"/>
+          </a:xfrm>
+          <a:prstGeom prst="straightConnector1">
+            <a:avLst/>
+          </a:prstGeom>
+          <a:ln>
+            <a:tailEnd type="triangle"/>
+          </a:ln>
+        </p:spPr>
+        <p:style>
+          <a:lnRef idx="2">
+            <a:schemeClr val="dk1"/>
+          </a:lnRef>
+          <a:fillRef idx="0">
+            <a:schemeClr val="dk1"/>
+          </a:fillRef>
+          <a:effectRef idx="1">
+            <a:schemeClr val="dk1"/>
+          </a:effectRef>
+          <a:fontRef idx="minor">
+            <a:schemeClr val="tx1"/>
+          </a:fontRef>
+        </p:style>
+      </p:cxnSp>
+      <p:cxnSp>
+        <p:nvCxnSpPr>
+          <p:cNvPr id="12" name="Straight Arrow Connector 11">
+            <a:extLst>
+              <a:ext uri="{FF2B5EF4-FFF2-40B4-BE49-F238E27FC236}">
+                <a16:creationId xmlns:a16="http://schemas.microsoft.com/office/drawing/2014/main" id="{AA6DCEF7-E600-F3DF-FED0-1C3757FC6585}"/>
+              </a:ext>
+            </a:extLst>
+          </p:cNvPr>
+          <p:cNvCxnSpPr>
+            <a:cxnSpLocks/>
+          </p:cNvCxnSpPr>
+          <p:nvPr/>
+        </p:nvCxnSpPr>
+        <p:spPr>
+          <a:xfrm>
+            <a:off x="8318738" y="5177860"/>
+            <a:ext cx="830801" cy="290368"/>
+          </a:xfrm>
+          <a:prstGeom prst="straightConnector1">
+            <a:avLst/>
+          </a:prstGeom>
+          <a:ln>
+            <a:tailEnd type="triangle"/>
+          </a:ln>
+        </p:spPr>
+        <p:style>
+          <a:lnRef idx="2">
+            <a:schemeClr val="dk1"/>
+          </a:lnRef>
+          <a:fillRef idx="0">
+            <a:schemeClr val="dk1"/>
+          </a:fillRef>
+          <a:effectRef idx="1">
+            <a:schemeClr val="dk1"/>
+          </a:effectRef>
+          <a:fontRef idx="minor">
+            <a:schemeClr val="tx1"/>
+          </a:fontRef>
+        </p:style>
+      </p:cxnSp>
+      <p:cxnSp>
+        <p:nvCxnSpPr>
+          <p:cNvPr id="13" name="Straight Arrow Connector 12">
+            <a:extLst>
+              <a:ext uri="{FF2B5EF4-FFF2-40B4-BE49-F238E27FC236}">
+                <a16:creationId xmlns:a16="http://schemas.microsoft.com/office/drawing/2014/main" id="{26A9BBC5-7015-BEDB-BB38-7D6FA15C062A}"/>
+              </a:ext>
+            </a:extLst>
+          </p:cNvPr>
+          <p:cNvCxnSpPr>
+            <a:cxnSpLocks/>
+          </p:cNvCxnSpPr>
+          <p:nvPr/>
+        </p:nvCxnSpPr>
+        <p:spPr>
+          <a:xfrm flipV="1">
+            <a:off x="9671035" y="3626115"/>
+            <a:ext cx="101315" cy="1626102"/>
+          </a:xfrm>
+          <a:prstGeom prst="straightConnector1">
+            <a:avLst/>
+          </a:prstGeom>
+          <a:ln>
+            <a:tailEnd type="triangle"/>
+          </a:ln>
+        </p:spPr>
+        <p:style>
+          <a:lnRef idx="2">
+            <a:schemeClr val="dk1"/>
+          </a:lnRef>
+          <a:fillRef idx="0">
+            <a:schemeClr val="dk1"/>
+          </a:fillRef>
+          <a:effectRef idx="1">
+            <a:schemeClr val="dk1"/>
+          </a:effectRef>
+          <a:fontRef idx="minor">
+            <a:schemeClr val="tx1"/>
+          </a:fontRef>
+        </p:style>
+      </p:cxnSp>
+      <p:sp>
+        <p:nvSpPr>
+          <p:cNvPr id="14" name="TextBox 13">
+            <a:extLst>
+              <a:ext uri="{FF2B5EF4-FFF2-40B4-BE49-F238E27FC236}">
+                <a16:creationId xmlns:a16="http://schemas.microsoft.com/office/drawing/2014/main" id="{FC997330-C90B-E474-A861-D9272D2E4F07}"/>
+              </a:ext>
+            </a:extLst>
+          </p:cNvPr>
+          <p:cNvSpPr txBox="1"/>
+          <p:nvPr/>
+        </p:nvSpPr>
+        <p:spPr>
+          <a:xfrm>
+            <a:off x="11353801" y="6368535"/>
+            <a:ext cx="633507" cy="369332"/>
+          </a:xfrm>
+          <a:prstGeom prst="rect">
+            <a:avLst/>
+          </a:prstGeom>
+          <a:noFill/>
+        </p:spPr>
+        <p:txBody>
+          <a:bodyPr wrap="none" rtlCol="0">
+            <a:spAutoFit/>
+          </a:bodyPr>
+          <a:lstStyle/>
+          <a:p>
+            <a:r>
+              <a:rPr lang="en-US" dirty="0"/>
+              <a:t>8/11</a:t>
+            </a:r>
+          </a:p>
+        </p:txBody>
+      </p:sp>
+    </p:spTree>
+    <p:extLst>
+      <p:ext uri="{BB962C8B-B14F-4D97-AF65-F5344CB8AC3E}">
+        <p14:creationId xmlns:p14="http://schemas.microsoft.com/office/powerpoint/2010/main" val="3639069372"/>
       </p:ext>
     </p:extLst>
   </p:cSld>
@@ -4639,4 +6576,319 @@
     </a:ext>
   </a:extLst>
 </a:theme>
+</file>
+
+<file path=ppt/theme/theme2.xml><?xml version="1.0" encoding="utf-8"?>
+<a:theme xmlns:a="http://schemas.openxmlformats.org/drawingml/2006/main" name="Office Theme">
+  <a:themeElements>
+    <a:clrScheme name="Office">
+      <a:dk1>
+        <a:sysClr val="windowText" lastClr="000000"/>
+      </a:dk1>
+      <a:lt1>
+        <a:sysClr val="window" lastClr="FFFFFF"/>
+      </a:lt1>
+      <a:dk2>
+        <a:srgbClr val="0E2841"/>
+      </a:dk2>
+      <a:lt2>
+        <a:srgbClr val="E8E8E8"/>
+      </a:lt2>
+      <a:accent1>
+        <a:srgbClr val="156082"/>
+      </a:accent1>
+      <a:accent2>
+        <a:srgbClr val="E97132"/>
+      </a:accent2>
+      <a:accent3>
+        <a:srgbClr val="196B24"/>
+      </a:accent3>
+      <a:accent4>
+        <a:srgbClr val="0F9ED5"/>
+      </a:accent4>
+      <a:accent5>
+        <a:srgbClr val="A02B93"/>
+      </a:accent5>
+      <a:accent6>
+        <a:srgbClr val="4EA72E"/>
+      </a:accent6>
+      <a:hlink>
+        <a:srgbClr val="467886"/>
+      </a:hlink>
+      <a:folHlink>
+        <a:srgbClr val="96607D"/>
+      </a:folHlink>
+    </a:clrScheme>
+    <a:fontScheme name="Office">
+      <a:majorFont>
+        <a:latin typeface="Aptos Display" panose="02110004020202020204"/>
+        <a:ea typeface=""/>
+        <a:cs typeface=""/>
+        <a:font script="Jpan" typeface="游ゴシック Light"/>
+        <a:font script="Hang" typeface="맑은 고딕"/>
+        <a:font script="Hans" typeface="等线 Light"/>
+        <a:font script="Hant" typeface="新細明體"/>
+        <a:font script="Arab" typeface="Times New Roman"/>
+        <a:font script="Hebr" typeface="Times New Roman"/>
+        <a:font script="Thai" typeface="Angsana New"/>
+        <a:font script="Ethi" typeface="Nyala"/>
+        <a:font script="Beng" typeface="Vrinda"/>
+        <a:font script="Gujr" typeface="Shruti"/>
+        <a:font script="Khmr" typeface="MoolBoran"/>
+        <a:font script="Knda" typeface="Tunga"/>
+        <a:font script="Guru" typeface="Raavi"/>
+        <a:font script="Cans" typeface="Euphemia"/>
+        <a:font script="Cher" typeface="Plantagenet Cherokee"/>
+        <a:font script="Yiii" typeface="Microsoft Yi Baiti"/>
+        <a:font script="Tibt" typeface="Microsoft Himalaya"/>
+        <a:font script="Thaa" typeface="MV Boli"/>
+        <a:font script="Deva" typeface="Mangal"/>
+        <a:font script="Telu" typeface="Gautami"/>
+        <a:font script="Taml" typeface="Latha"/>
+        <a:font script="Syrc" typeface="Estrangelo Edessa"/>
+        <a:font script="Orya" typeface="Kalinga"/>
+        <a:font script="Mlym" typeface="Kartika"/>
+        <a:font script="Laoo" typeface="DokChampa"/>
+        <a:font script="Sinh" typeface="Iskoola Pota"/>
+        <a:font script="Mong" typeface="Mongolian Baiti"/>
+        <a:font script="Viet" typeface="Times New Roman"/>
+        <a:font script="Uigh" typeface="Microsoft Uighur"/>
+        <a:font script="Geor" typeface="Sylfaen"/>
+        <a:font script="Armn" typeface="Arial"/>
+        <a:font script="Bugi" typeface="Leelawadee UI"/>
+        <a:font script="Bopo" typeface="Microsoft JhengHei"/>
+        <a:font script="Java" typeface="Javanese Text"/>
+        <a:font script="Lisu" typeface="Segoe UI"/>
+        <a:font script="Mymr" typeface="Myanmar Text"/>
+        <a:font script="Nkoo" typeface="Ebrima"/>
+        <a:font script="Olck" typeface="Nirmala UI"/>
+        <a:font script="Osma" typeface="Ebrima"/>
+        <a:font script="Phag" typeface="Phagspa"/>
+        <a:font script="Syrn" typeface="Estrangelo Edessa"/>
+        <a:font script="Syrj" typeface="Estrangelo Edessa"/>
+        <a:font script="Syre" typeface="Estrangelo Edessa"/>
+        <a:font script="Sora" typeface="Nirmala UI"/>
+        <a:font script="Tale" typeface="Microsoft Tai Le"/>
+        <a:font script="Talu" typeface="Microsoft New Tai Lue"/>
+        <a:font script="Tfng" typeface="Ebrima"/>
+      </a:majorFont>
+      <a:minorFont>
+        <a:latin typeface="Aptos" panose="02110004020202020204"/>
+        <a:ea typeface=""/>
+        <a:cs typeface=""/>
+        <a:font script="Jpan" typeface="游ゴシック"/>
+        <a:font script="Hang" typeface="맑은 고딕"/>
+        <a:font script="Hans" typeface="等线"/>
+        <a:font script="Hant" typeface="新細明體"/>
+        <a:font script="Arab" typeface="Arial"/>
+        <a:font script="Hebr" typeface="Arial"/>
+        <a:font script="Thai" typeface="Cordia New"/>
+        <a:font script="Ethi" typeface="Nyala"/>
+        <a:font script="Beng" typeface="Vrinda"/>
+        <a:font script="Gujr" typeface="Shruti"/>
+        <a:font script="Khmr" typeface="DaunPenh"/>
+        <a:font script="Knda" typeface="Tunga"/>
+        <a:font script="Guru" typeface="Raavi"/>
+        <a:font script="Cans" typeface="Euphemia"/>
+        <a:font script="Cher" typeface="Plantagenet Cherokee"/>
+        <a:font script="Yiii" typeface="Microsoft Yi Baiti"/>
+        <a:font script="Tibt" typeface="Microsoft Himalaya"/>
+        <a:font script="Thaa" typeface="MV Boli"/>
+        <a:font script="Deva" typeface="Mangal"/>
+        <a:font script="Telu" typeface="Gautami"/>
+        <a:font script="Taml" typeface="Latha"/>
+        <a:font script="Syrc" typeface="Estrangelo Edessa"/>
+        <a:font script="Orya" typeface="Kalinga"/>
+        <a:font script="Mlym" typeface="Kartika"/>
+        <a:font script="Laoo" typeface="DokChampa"/>
+        <a:font script="Sinh" typeface="Iskoola Pota"/>
+        <a:font script="Mong" typeface="Mongolian Baiti"/>
+        <a:font script="Viet" typeface="Arial"/>
+        <a:font script="Uigh" typeface="Microsoft Uighur"/>
+        <a:font script="Geor" typeface="Sylfaen"/>
+        <a:font script="Armn" typeface="Arial"/>
+        <a:font script="Bugi" typeface="Leelawadee UI"/>
+        <a:font script="Bopo" typeface="Microsoft JhengHei"/>
+        <a:font script="Java" typeface="Javanese Text"/>
+        <a:font script="Lisu" typeface="Segoe UI"/>
+        <a:font script="Mymr" typeface="Myanmar Text"/>
+        <a:font script="Nkoo" typeface="Ebrima"/>
+        <a:font script="Olck" typeface="Nirmala UI"/>
+        <a:font script="Osma" typeface="Ebrima"/>
+        <a:font script="Phag" typeface="Phagspa"/>
+        <a:font script="Syrn" typeface="Estrangelo Edessa"/>
+        <a:font script="Syrj" typeface="Estrangelo Edessa"/>
+        <a:font script="Syre" typeface="Estrangelo Edessa"/>
+        <a:font script="Sora" typeface="Nirmala UI"/>
+        <a:font script="Tale" typeface="Microsoft Tai Le"/>
+        <a:font script="Talu" typeface="Microsoft New Tai Lue"/>
+        <a:font script="Tfng" typeface="Ebrima"/>
+      </a:minorFont>
+    </a:fontScheme>
+    <a:fmtScheme name="Office">
+      <a:fillStyleLst>
+        <a:solidFill>
+          <a:schemeClr val="phClr"/>
+        </a:solidFill>
+        <a:gradFill rotWithShape="1">
+          <a:gsLst>
+            <a:gs pos="0">
+              <a:schemeClr val="phClr">
+                <a:lumMod val="110000"/>
+                <a:satMod val="105000"/>
+                <a:tint val="67000"/>
+              </a:schemeClr>
+            </a:gs>
+            <a:gs pos="50000">
+              <a:schemeClr val="phClr">
+                <a:lumMod val="105000"/>
+                <a:satMod val="103000"/>
+                <a:tint val="73000"/>
+              </a:schemeClr>
+            </a:gs>
+            <a:gs pos="100000">
+              <a:schemeClr val="phClr">
+                <a:lumMod val="105000"/>
+                <a:satMod val="109000"/>
+                <a:tint val="81000"/>
+              </a:schemeClr>
+            </a:gs>
+          </a:gsLst>
+          <a:lin ang="5400000" scaled="0"/>
+        </a:gradFill>
+        <a:gradFill rotWithShape="1">
+          <a:gsLst>
+            <a:gs pos="0">
+              <a:schemeClr val="phClr">
+                <a:satMod val="103000"/>
+                <a:lumMod val="102000"/>
+                <a:tint val="94000"/>
+              </a:schemeClr>
+            </a:gs>
+            <a:gs pos="50000">
+              <a:schemeClr val="phClr">
+                <a:satMod val="110000"/>
+                <a:lumMod val="100000"/>
+                <a:shade val="100000"/>
+              </a:schemeClr>
+            </a:gs>
+            <a:gs pos="100000">
+              <a:schemeClr val="phClr">
+                <a:lumMod val="99000"/>
+                <a:satMod val="120000"/>
+                <a:shade val="78000"/>
+              </a:schemeClr>
+            </a:gs>
+          </a:gsLst>
+          <a:lin ang="5400000" scaled="0"/>
+        </a:gradFill>
+      </a:fillStyleLst>
+      <a:lnStyleLst>
+        <a:ln w="12700" cap="flat" cmpd="sng" algn="ctr">
+          <a:solidFill>
+            <a:schemeClr val="phClr"/>
+          </a:solidFill>
+          <a:prstDash val="solid"/>
+          <a:miter lim="800000"/>
+        </a:ln>
+        <a:ln w="19050" cap="flat" cmpd="sng" algn="ctr">
+          <a:solidFill>
+            <a:schemeClr val="phClr"/>
+          </a:solidFill>
+          <a:prstDash val="solid"/>
+          <a:miter lim="800000"/>
+        </a:ln>
+        <a:ln w="25400" cap="flat" cmpd="sng" algn="ctr">
+          <a:solidFill>
+            <a:schemeClr val="phClr"/>
+          </a:solidFill>
+          <a:prstDash val="solid"/>
+          <a:miter lim="800000"/>
+        </a:ln>
+      </a:lnStyleLst>
+      <a:effectStyleLst>
+        <a:effectStyle>
+          <a:effectLst/>
+        </a:effectStyle>
+        <a:effectStyle>
+          <a:effectLst/>
+        </a:effectStyle>
+        <a:effectStyle>
+          <a:effectLst>
+            <a:outerShdw blurRad="57150" dist="19050" dir="5400000" algn="ctr" rotWithShape="0">
+              <a:srgbClr val="000000">
+                <a:alpha val="63000"/>
+              </a:srgbClr>
+            </a:outerShdw>
+          </a:effectLst>
+        </a:effectStyle>
+      </a:effectStyleLst>
+      <a:bgFillStyleLst>
+        <a:solidFill>
+          <a:schemeClr val="phClr"/>
+        </a:solidFill>
+        <a:solidFill>
+          <a:schemeClr val="phClr">
+            <a:tint val="95000"/>
+            <a:satMod val="170000"/>
+          </a:schemeClr>
+        </a:solidFill>
+        <a:gradFill rotWithShape="1">
+          <a:gsLst>
+            <a:gs pos="0">
+              <a:schemeClr val="phClr">
+                <a:tint val="93000"/>
+                <a:satMod val="150000"/>
+                <a:shade val="98000"/>
+                <a:lumMod val="102000"/>
+              </a:schemeClr>
+            </a:gs>
+            <a:gs pos="50000">
+              <a:schemeClr val="phClr">
+                <a:tint val="98000"/>
+                <a:satMod val="130000"/>
+                <a:shade val="90000"/>
+                <a:lumMod val="103000"/>
+              </a:schemeClr>
+            </a:gs>
+            <a:gs pos="100000">
+              <a:schemeClr val="phClr">
+                <a:shade val="63000"/>
+                <a:satMod val="120000"/>
+              </a:schemeClr>
+            </a:gs>
+          </a:gsLst>
+          <a:lin ang="5400000" scaled="0"/>
+        </a:gradFill>
+      </a:bgFillStyleLst>
+    </a:fmtScheme>
+  </a:themeElements>
+  <a:objectDefaults>
+    <a:lnDef>
+      <a:spPr/>
+      <a:bodyPr/>
+      <a:lstStyle/>
+      <a:style>
+        <a:lnRef idx="2">
+          <a:schemeClr val="accent1"/>
+        </a:lnRef>
+        <a:fillRef idx="0">
+          <a:schemeClr val="accent1"/>
+        </a:fillRef>
+        <a:effectRef idx="1">
+          <a:schemeClr val="accent1"/>
+        </a:effectRef>
+        <a:fontRef idx="minor">
+          <a:schemeClr val="tx1"/>
+        </a:fontRef>
+      </a:style>
+    </a:lnDef>
+  </a:objectDefaults>
+  <a:extraClrSchemeLst/>
+  <a:extLst>
+    <a:ext uri="{05A4C25C-085E-4340-85A3-A5531E510DB2}">
+      <thm15:themeFamily xmlns:thm15="http://schemas.microsoft.com/office/thememl/2012/main" name="Office Theme" id="{2E142A2C-CD16-42D6-873A-C26D2A0506FA}" vid="{1BDDFF52-6CD6-40A5-AB3C-68EB2F1E4D0A}"/>
+    </a:ext>
+  </a:extLst>
+</a:theme>
 </file>
</xml_diff>

<commit_message>
added exterior variables. Addedd unit testing. Meteorite not included yet
</commit_message>
<xml_diff>
--- a/Documentation/CDCM Diagrams .pptx
+++ b/Documentation/CDCM Diagrams .pptx
@@ -5,12 +5,13 @@
     <p:sldMasterId id="2147483648" r:id="rId1"/>
   </p:sldMasterIdLst>
   <p:notesMasterIdLst>
-    <p:notesMasterId r:id="rId5"/>
+    <p:notesMasterId r:id="rId6"/>
   </p:notesMasterIdLst>
   <p:sldIdLst>
     <p:sldId id="256" r:id="rId2"/>
     <p:sldId id="258" r:id="rId3"/>
     <p:sldId id="257" r:id="rId4"/>
+    <p:sldId id="259" r:id="rId5"/>
   </p:sldIdLst>
   <p:sldSz cx="12192000" cy="6858000"/>
   <p:notesSz cx="6858000" cy="9144000"/>
@@ -199,7 +200,7 @@
           <a:p>
             <a:fld id="{94EF214D-1F76-F841-A2D3-D2CDEC996226}" type="datetimeFigureOut">
               <a:rPr lang="en-US" smtClean="0"/>
-              <a:t>8/11/25</a:t>
+              <a:t>8/26/25</a:t>
             </a:fld>
             <a:endParaRPr lang="en-US"/>
           </a:p>
@@ -697,7 +698,7 @@
           <a:p>
             <a:fld id="{E90F38FF-858C-0643-98FD-89636F5F9C82}" type="datetimeFigureOut">
               <a:rPr lang="en-US" smtClean="0"/>
-              <a:t>8/11/25</a:t>
+              <a:t>8/26/25</a:t>
             </a:fld>
             <a:endParaRPr lang="en-US"/>
           </a:p>
@@ -895,7 +896,7 @@
           <a:p>
             <a:fld id="{E90F38FF-858C-0643-98FD-89636F5F9C82}" type="datetimeFigureOut">
               <a:rPr lang="en-US" smtClean="0"/>
-              <a:t>8/11/25</a:t>
+              <a:t>8/26/25</a:t>
             </a:fld>
             <a:endParaRPr lang="en-US"/>
           </a:p>
@@ -1103,7 +1104,7 @@
           <a:p>
             <a:fld id="{E90F38FF-858C-0643-98FD-89636F5F9C82}" type="datetimeFigureOut">
               <a:rPr lang="en-US" smtClean="0"/>
-              <a:t>8/11/25</a:t>
+              <a:t>8/26/25</a:t>
             </a:fld>
             <a:endParaRPr lang="en-US"/>
           </a:p>
@@ -1301,7 +1302,7 @@
           <a:p>
             <a:fld id="{E90F38FF-858C-0643-98FD-89636F5F9C82}" type="datetimeFigureOut">
               <a:rPr lang="en-US" smtClean="0"/>
-              <a:t>8/11/25</a:t>
+              <a:t>8/26/25</a:t>
             </a:fld>
             <a:endParaRPr lang="en-US"/>
           </a:p>
@@ -1576,7 +1577,7 @@
           <a:p>
             <a:fld id="{E90F38FF-858C-0643-98FD-89636F5F9C82}" type="datetimeFigureOut">
               <a:rPr lang="en-US" smtClean="0"/>
-              <a:t>8/11/25</a:t>
+              <a:t>8/26/25</a:t>
             </a:fld>
             <a:endParaRPr lang="en-US"/>
           </a:p>
@@ -1841,7 +1842,7 @@
           <a:p>
             <a:fld id="{E90F38FF-858C-0643-98FD-89636F5F9C82}" type="datetimeFigureOut">
               <a:rPr lang="en-US" smtClean="0"/>
-              <a:t>8/11/25</a:t>
+              <a:t>8/26/25</a:t>
             </a:fld>
             <a:endParaRPr lang="en-US"/>
           </a:p>
@@ -2253,7 +2254,7 @@
           <a:p>
             <a:fld id="{E90F38FF-858C-0643-98FD-89636F5F9C82}" type="datetimeFigureOut">
               <a:rPr lang="en-US" smtClean="0"/>
-              <a:t>8/11/25</a:t>
+              <a:t>8/26/25</a:t>
             </a:fld>
             <a:endParaRPr lang="en-US"/>
           </a:p>
@@ -2394,7 +2395,7 @@
           <a:p>
             <a:fld id="{E90F38FF-858C-0643-98FD-89636F5F9C82}" type="datetimeFigureOut">
               <a:rPr lang="en-US" smtClean="0"/>
-              <a:t>8/11/25</a:t>
+              <a:t>8/26/25</a:t>
             </a:fld>
             <a:endParaRPr lang="en-US"/>
           </a:p>
@@ -2507,7 +2508,7 @@
           <a:p>
             <a:fld id="{E90F38FF-858C-0643-98FD-89636F5F9C82}" type="datetimeFigureOut">
               <a:rPr lang="en-US" smtClean="0"/>
-              <a:t>8/11/25</a:t>
+              <a:t>8/26/25</a:t>
             </a:fld>
             <a:endParaRPr lang="en-US"/>
           </a:p>
@@ -2818,7 +2819,7 @@
           <a:p>
             <a:fld id="{E90F38FF-858C-0643-98FD-89636F5F9C82}" type="datetimeFigureOut">
               <a:rPr lang="en-US" smtClean="0"/>
-              <a:t>8/11/25</a:t>
+              <a:t>8/26/25</a:t>
             </a:fld>
             <a:endParaRPr lang="en-US"/>
           </a:p>
@@ -3106,7 +3107,7 @@
           <a:p>
             <a:fld id="{E90F38FF-858C-0643-98FD-89636F5F9C82}" type="datetimeFigureOut">
               <a:rPr lang="en-US" smtClean="0"/>
-              <a:t>8/11/25</a:t>
+              <a:t>8/26/25</a:t>
             </a:fld>
             <a:endParaRPr lang="en-US"/>
           </a:p>
@@ -3347,7 +3348,7 @@
           <a:p>
             <a:fld id="{E90F38FF-858C-0643-98FD-89636F5F9C82}" type="datetimeFigureOut">
               <a:rPr lang="en-US" smtClean="0"/>
-              <a:t>8/11/25</a:t>
+              <a:t>8/26/25</a:t>
             </a:fld>
             <a:endParaRPr lang="en-US"/>
           </a:p>
@@ -5488,8 +5489,8 @@
           <a:chExt cx="0" cy="0"/>
         </a:xfrm>
       </p:grpSpPr>
-      <mc:AlternateContent xmlns:mc="http://schemas.openxmlformats.org/markup-compatibility/2006">
-        <mc:Choice xmlns:a14="http://schemas.microsoft.com/office/drawing/2010/main" Requires="a14">
+      <mc:AlternateContent xmlns:mc="http://schemas.openxmlformats.org/markup-compatibility/2006" xmlns:a14="http://schemas.microsoft.com/office/drawing/2010/main">
+        <mc:Choice Requires="a14">
           <p:sp>
             <p:nvSpPr>
               <p:cNvPr id="5" name="Oval 4">
@@ -5555,7 +5556,7 @@
             </p:txBody>
           </p:sp>
         </mc:Choice>
-        <mc:Fallback>
+        <mc:Fallback xmlns="">
           <p:sp>
             <p:nvSpPr>
               <p:cNvPr id="5" name="Oval 4">
@@ -5600,8 +5601,8 @@
           </p:sp>
         </mc:Fallback>
       </mc:AlternateContent>
-      <mc:AlternateContent xmlns:mc="http://schemas.openxmlformats.org/markup-compatibility/2006">
-        <mc:Choice xmlns:a14="http://schemas.microsoft.com/office/drawing/2010/main" Requires="a14">
+      <mc:AlternateContent xmlns:mc="http://schemas.openxmlformats.org/markup-compatibility/2006" xmlns:a14="http://schemas.microsoft.com/office/drawing/2010/main">
+        <mc:Choice Requires="a14">
           <p:sp>
             <p:nvSpPr>
               <p:cNvPr id="6" name="Oval 5">
@@ -5709,7 +5710,7 @@
             </p:txBody>
           </p:sp>
         </mc:Choice>
-        <mc:Fallback>
+        <mc:Fallback xmlns="">
           <p:sp>
             <p:nvSpPr>
               <p:cNvPr id="6" name="Oval 5">
@@ -5754,8 +5755,8 @@
           </p:sp>
         </mc:Fallback>
       </mc:AlternateContent>
-      <mc:AlternateContent xmlns:mc="http://schemas.openxmlformats.org/markup-compatibility/2006">
-        <mc:Choice xmlns:a14="http://schemas.microsoft.com/office/drawing/2010/main" Requires="a14">
+      <mc:AlternateContent xmlns:mc="http://schemas.openxmlformats.org/markup-compatibility/2006" xmlns:a14="http://schemas.microsoft.com/office/drawing/2010/main">
+        <mc:Choice Requires="a14">
           <p:sp>
             <p:nvSpPr>
               <p:cNvPr id="7" name="Oval 6">
@@ -5838,7 +5839,7 @@
             </p:txBody>
           </p:sp>
         </mc:Choice>
-        <mc:Fallback>
+        <mc:Fallback xmlns="">
           <p:sp>
             <p:nvSpPr>
               <p:cNvPr id="7" name="Oval 6">
@@ -5883,8 +5884,8 @@
           </p:sp>
         </mc:Fallback>
       </mc:AlternateContent>
-      <mc:AlternateContent xmlns:mc="http://schemas.openxmlformats.org/markup-compatibility/2006">
-        <mc:Choice xmlns:a14="http://schemas.microsoft.com/office/drawing/2010/main" Requires="a14">
+      <mc:AlternateContent xmlns:mc="http://schemas.openxmlformats.org/markup-compatibility/2006" xmlns:a14="http://schemas.microsoft.com/office/drawing/2010/main">
+        <mc:Choice Requires="a14">
           <p:sp>
             <p:nvSpPr>
               <p:cNvPr id="8" name="Oval 7">
@@ -5967,7 +5968,7 @@
             </p:txBody>
           </p:sp>
         </mc:Choice>
-        <mc:Fallback>
+        <mc:Fallback xmlns="">
           <p:sp>
             <p:nvSpPr>
               <p:cNvPr id="8" name="Oval 7">
@@ -6254,6 +6255,72 @@
     <p:extLst>
       <p:ext uri="{BB962C8B-B14F-4D97-AF65-F5344CB8AC3E}">
         <p14:creationId xmlns:p14="http://schemas.microsoft.com/office/powerpoint/2010/main" val="3639069372"/>
+      </p:ext>
+    </p:extLst>
+  </p:cSld>
+  <p:clrMapOvr>
+    <a:masterClrMapping/>
+  </p:clrMapOvr>
+</p:sld>
+</file>
+
+<file path=ppt/slides/slide4.xml><?xml version="1.0" encoding="utf-8"?>
+<p:sld xmlns:a="http://schemas.openxmlformats.org/drawingml/2006/main" xmlns:r="http://schemas.openxmlformats.org/officeDocument/2006/relationships" xmlns:p="http://schemas.openxmlformats.org/presentationml/2006/main">
+  <p:cSld>
+    <p:spTree>
+      <p:nvGrpSpPr>
+        <p:cNvPr id="1" name=""/>
+        <p:cNvGrpSpPr/>
+        <p:nvPr/>
+      </p:nvGrpSpPr>
+      <p:grpSpPr>
+        <a:xfrm>
+          <a:off x="0" y="0"/>
+          <a:ext cx="0" cy="0"/>
+          <a:chOff x="0" y="0"/>
+          <a:chExt cx="0" cy="0"/>
+        </a:xfrm>
+      </p:grpSpPr>
+      <p:sp>
+        <p:nvSpPr>
+          <p:cNvPr id="14" name="TextBox 13">
+            <a:extLst>
+              <a:ext uri="{FF2B5EF4-FFF2-40B4-BE49-F238E27FC236}">
+                <a16:creationId xmlns:a16="http://schemas.microsoft.com/office/drawing/2014/main" id="{FC997330-C90B-E474-A861-D9272D2E4F07}"/>
+              </a:ext>
+            </a:extLst>
+          </p:cNvPr>
+          <p:cNvSpPr txBox="1"/>
+          <p:nvPr/>
+        </p:nvSpPr>
+        <p:spPr>
+          <a:xfrm>
+            <a:off x="11353801" y="6368535"/>
+            <a:ext cx="633507" cy="369332"/>
+          </a:xfrm>
+          <a:prstGeom prst="rect">
+            <a:avLst/>
+          </a:prstGeom>
+          <a:noFill/>
+        </p:spPr>
+        <p:txBody>
+          <a:bodyPr wrap="none" rtlCol="0">
+            <a:spAutoFit/>
+          </a:bodyPr>
+          <a:lstStyle/>
+          <a:p>
+            <a:r>
+              <a:rPr lang="en-US"/>
+              <a:t>8/26</a:t>
+            </a:r>
+            <a:endParaRPr lang="en-US" dirty="0"/>
+          </a:p>
+        </p:txBody>
+      </p:sp>
+    </p:spTree>
+    <p:extLst>
+      <p:ext uri="{BB962C8B-B14F-4D97-AF65-F5344CB8AC3E}">
+        <p14:creationId xmlns:p14="http://schemas.microsoft.com/office/powerpoint/2010/main" val="300857298"/>
       </p:ext>
     </p:extLst>
   </p:cSld>

</xml_diff>

<commit_message>
updated solar panel file
</commit_message>
<xml_diff>
--- a/Documentation/CDCM Diagrams .pptx
+++ b/Documentation/CDCM Diagrams .pptx
@@ -5,13 +5,14 @@
     <p:sldMasterId id="2147483648" r:id="rId1"/>
   </p:sldMasterIdLst>
   <p:notesMasterIdLst>
-    <p:notesMasterId r:id="rId6"/>
+    <p:notesMasterId r:id="rId7"/>
   </p:notesMasterIdLst>
   <p:sldIdLst>
     <p:sldId id="256" r:id="rId2"/>
     <p:sldId id="258" r:id="rId3"/>
     <p:sldId id="257" r:id="rId4"/>
     <p:sldId id="259" r:id="rId5"/>
+    <p:sldId id="260" r:id="rId6"/>
   </p:sldIdLst>
   <p:sldSz cx="12192000" cy="6858000"/>
   <p:notesSz cx="6858000" cy="9144000"/>
@@ -200,7 +201,7 @@
           <a:p>
             <a:fld id="{94EF214D-1F76-F841-A2D3-D2CDEC996226}" type="datetimeFigureOut">
               <a:rPr lang="en-US" smtClean="0"/>
-              <a:t>8/26/25</a:t>
+              <a:t>8/28/25</a:t>
             </a:fld>
             <a:endParaRPr lang="en-US"/>
           </a:p>
@@ -698,7 +699,7 @@
           <a:p>
             <a:fld id="{E90F38FF-858C-0643-98FD-89636F5F9C82}" type="datetimeFigureOut">
               <a:rPr lang="en-US" smtClean="0"/>
-              <a:t>8/26/25</a:t>
+              <a:t>8/28/25</a:t>
             </a:fld>
             <a:endParaRPr lang="en-US"/>
           </a:p>
@@ -896,7 +897,7 @@
           <a:p>
             <a:fld id="{E90F38FF-858C-0643-98FD-89636F5F9C82}" type="datetimeFigureOut">
               <a:rPr lang="en-US" smtClean="0"/>
-              <a:t>8/26/25</a:t>
+              <a:t>8/28/25</a:t>
             </a:fld>
             <a:endParaRPr lang="en-US"/>
           </a:p>
@@ -1104,7 +1105,7 @@
           <a:p>
             <a:fld id="{E90F38FF-858C-0643-98FD-89636F5F9C82}" type="datetimeFigureOut">
               <a:rPr lang="en-US" smtClean="0"/>
-              <a:t>8/26/25</a:t>
+              <a:t>8/28/25</a:t>
             </a:fld>
             <a:endParaRPr lang="en-US"/>
           </a:p>
@@ -1302,7 +1303,7 @@
           <a:p>
             <a:fld id="{E90F38FF-858C-0643-98FD-89636F5F9C82}" type="datetimeFigureOut">
               <a:rPr lang="en-US" smtClean="0"/>
-              <a:t>8/26/25</a:t>
+              <a:t>8/28/25</a:t>
             </a:fld>
             <a:endParaRPr lang="en-US"/>
           </a:p>
@@ -1577,7 +1578,7 @@
           <a:p>
             <a:fld id="{E90F38FF-858C-0643-98FD-89636F5F9C82}" type="datetimeFigureOut">
               <a:rPr lang="en-US" smtClean="0"/>
-              <a:t>8/26/25</a:t>
+              <a:t>8/28/25</a:t>
             </a:fld>
             <a:endParaRPr lang="en-US"/>
           </a:p>
@@ -1842,7 +1843,7 @@
           <a:p>
             <a:fld id="{E90F38FF-858C-0643-98FD-89636F5F9C82}" type="datetimeFigureOut">
               <a:rPr lang="en-US" smtClean="0"/>
-              <a:t>8/26/25</a:t>
+              <a:t>8/28/25</a:t>
             </a:fld>
             <a:endParaRPr lang="en-US"/>
           </a:p>
@@ -2254,7 +2255,7 @@
           <a:p>
             <a:fld id="{E90F38FF-858C-0643-98FD-89636F5F9C82}" type="datetimeFigureOut">
               <a:rPr lang="en-US" smtClean="0"/>
-              <a:t>8/26/25</a:t>
+              <a:t>8/28/25</a:t>
             </a:fld>
             <a:endParaRPr lang="en-US"/>
           </a:p>
@@ -2395,7 +2396,7 @@
           <a:p>
             <a:fld id="{E90F38FF-858C-0643-98FD-89636F5F9C82}" type="datetimeFigureOut">
               <a:rPr lang="en-US" smtClean="0"/>
-              <a:t>8/26/25</a:t>
+              <a:t>8/28/25</a:t>
             </a:fld>
             <a:endParaRPr lang="en-US"/>
           </a:p>
@@ -2508,7 +2509,7 @@
           <a:p>
             <a:fld id="{E90F38FF-858C-0643-98FD-89636F5F9C82}" type="datetimeFigureOut">
               <a:rPr lang="en-US" smtClean="0"/>
-              <a:t>8/26/25</a:t>
+              <a:t>8/28/25</a:t>
             </a:fld>
             <a:endParaRPr lang="en-US"/>
           </a:p>
@@ -2819,7 +2820,7 @@
           <a:p>
             <a:fld id="{E90F38FF-858C-0643-98FD-89636F5F9C82}" type="datetimeFigureOut">
               <a:rPr lang="en-US" smtClean="0"/>
-              <a:t>8/26/25</a:t>
+              <a:t>8/28/25</a:t>
             </a:fld>
             <a:endParaRPr lang="en-US"/>
           </a:p>
@@ -3107,7 +3108,7 @@
           <a:p>
             <a:fld id="{E90F38FF-858C-0643-98FD-89636F5F9C82}" type="datetimeFigureOut">
               <a:rPr lang="en-US" smtClean="0"/>
-              <a:t>8/26/25</a:t>
+              <a:t>8/28/25</a:t>
             </a:fld>
             <a:endParaRPr lang="en-US"/>
           </a:p>
@@ -3348,7 +3349,7 @@
           <a:p>
             <a:fld id="{E90F38FF-858C-0643-98FD-89636F5F9C82}" type="datetimeFigureOut">
               <a:rPr lang="en-US" smtClean="0"/>
-              <a:t>8/26/25</a:t>
+              <a:t>8/28/25</a:t>
             </a:fld>
             <a:endParaRPr lang="en-US"/>
           </a:p>
@@ -9882,6 +9883,706 @@
     <p:extLst>
       <p:ext uri="{BB962C8B-B14F-4D97-AF65-F5344CB8AC3E}">
         <p14:creationId xmlns:p14="http://schemas.microsoft.com/office/powerpoint/2010/main" val="300857298"/>
+      </p:ext>
+    </p:extLst>
+  </p:cSld>
+  <p:clrMapOvr>
+    <a:masterClrMapping/>
+  </p:clrMapOvr>
+</p:sld>
+</file>
+
+<file path=ppt/slides/slide5.xml><?xml version="1.0" encoding="utf-8"?>
+<p:sld xmlns:a="http://schemas.openxmlformats.org/drawingml/2006/main" xmlns:r="http://schemas.openxmlformats.org/officeDocument/2006/relationships" xmlns:p="http://schemas.openxmlformats.org/presentationml/2006/main">
+  <p:cSld>
+    <p:spTree>
+      <p:nvGrpSpPr>
+        <p:cNvPr id="1" name=""/>
+        <p:cNvGrpSpPr/>
+        <p:nvPr/>
+      </p:nvGrpSpPr>
+      <p:grpSpPr>
+        <a:xfrm>
+          <a:off x="0" y="0"/>
+          <a:ext cx="0" cy="0"/>
+          <a:chOff x="0" y="0"/>
+          <a:chExt cx="0" cy="0"/>
+        </a:xfrm>
+      </p:grpSpPr>
+      <mc:AlternateContent xmlns:mc="http://schemas.openxmlformats.org/markup-compatibility/2006">
+        <mc:Choice xmlns:a14="http://schemas.microsoft.com/office/drawing/2010/main" Requires="a14">
+          <p:sp>
+            <p:nvSpPr>
+              <p:cNvPr id="5" name="Oval 4">
+                <a:extLst>
+                  <a:ext uri="{FF2B5EF4-FFF2-40B4-BE49-F238E27FC236}">
+                    <a16:creationId xmlns:a16="http://schemas.microsoft.com/office/drawing/2014/main" id="{BDC0D858-280B-85CF-0BA4-240F092DAD2C}"/>
+                  </a:ext>
+                </a:extLst>
+              </p:cNvPr>
+              <p:cNvSpPr/>
+              <p:nvPr/>
+            </p:nvSpPr>
+            <p:spPr>
+              <a:xfrm>
+                <a:off x="3105573" y="3918857"/>
+                <a:ext cx="1475014" cy="1475014"/>
+              </a:xfrm>
+              <a:prstGeom prst="ellipse">
+                <a:avLst/>
+              </a:prstGeom>
+              <a:solidFill>
+                <a:schemeClr val="bg1">
+                  <a:lumMod val="85000"/>
+                </a:schemeClr>
+              </a:solidFill>
+            </p:spPr>
+            <p:style>
+              <a:lnRef idx="1">
+                <a:schemeClr val="dk1"/>
+              </a:lnRef>
+              <a:fillRef idx="2">
+                <a:schemeClr val="dk1"/>
+              </a:fillRef>
+              <a:effectRef idx="1">
+                <a:schemeClr val="dk1"/>
+              </a:effectRef>
+              <a:fontRef idx="minor">
+                <a:schemeClr val="dk1"/>
+              </a:fontRef>
+            </p:style>
+            <p:txBody>
+              <a:bodyPr rtlCol="0" anchor="ctr"/>
+              <a:lstStyle/>
+              <a:p>
+                <a:pPr algn="ctr"/>
+                <a14:m>
+                  <m:oMathPara xmlns:m="http://schemas.openxmlformats.org/officeDocument/2006/math">
+                    <m:oMathParaPr>
+                      <m:jc m:val="centerGroup"/>
+                    </m:oMathParaPr>
+                    <m:oMath xmlns:m="http://schemas.openxmlformats.org/officeDocument/2006/math">
+                      <m:r>
+                        <a:rPr lang="en-US" b="0" i="1" smtClean="0">
+                          <a:latin typeface="Cambria Math" panose="02040503050406030204" pitchFamily="18" charset="0"/>
+                        </a:rPr>
+                        <m:t>𝑆𝑜𝑙𝑎𝑟</m:t>
+                      </m:r>
+                      <m:r>
+                        <a:rPr lang="en-US" b="0" i="1" smtClean="0">
+                          <a:latin typeface="Cambria Math" panose="02040503050406030204" pitchFamily="18" charset="0"/>
+                        </a:rPr>
+                        <m:t> </m:t>
+                      </m:r>
+                      <m:r>
+                        <a:rPr lang="en-US" b="0" i="1" smtClean="0">
+                          <a:latin typeface="Cambria Math" panose="02040503050406030204" pitchFamily="18" charset="0"/>
+                        </a:rPr>
+                        <m:t>𝑃𝑎𝑛𝑒𝑙𝑠</m:t>
+                      </m:r>
+                    </m:oMath>
+                  </m:oMathPara>
+                </a14:m>
+                <a:endParaRPr lang="en-US" dirty="0"/>
+              </a:p>
+            </p:txBody>
+          </p:sp>
+        </mc:Choice>
+        <mc:Fallback>
+          <p:sp>
+            <p:nvSpPr>
+              <p:cNvPr id="5" name="Oval 4">
+                <a:extLst>
+                  <a:ext uri="{FF2B5EF4-FFF2-40B4-BE49-F238E27FC236}">
+                    <a16:creationId xmlns:a16="http://schemas.microsoft.com/office/drawing/2014/main" id="{BDC0D858-280B-85CF-0BA4-240F092DAD2C}"/>
+                  </a:ext>
+                </a:extLst>
+              </p:cNvPr>
+              <p:cNvSpPr>
+                <a:spLocks noRot="1" noChangeAspect="1" noMove="1" noResize="1" noEditPoints="1" noAdjustHandles="1" noChangeArrowheads="1" noChangeShapeType="1" noTextEdit="1"/>
+              </p:cNvSpPr>
+              <p:nvPr/>
+            </p:nvSpPr>
+            <p:spPr>
+              <a:xfrm>
+                <a:off x="3105573" y="3918857"/>
+                <a:ext cx="1475014" cy="1475014"/>
+              </a:xfrm>
+              <a:prstGeom prst="ellipse">
+                <a:avLst/>
+              </a:prstGeom>
+              <a:blipFill>
+                <a:blip r:embed="rId2"/>
+                <a:stretch>
+                  <a:fillRect l="-847"/>
+                </a:stretch>
+              </a:blipFill>
+            </p:spPr>
+            <p:txBody>
+              <a:bodyPr/>
+              <a:lstStyle/>
+              <a:p>
+                <a:r>
+                  <a:rPr lang="en-US">
+                    <a:noFill/>
+                  </a:rPr>
+                  <a:t> </a:t>
+                </a:r>
+              </a:p>
+            </p:txBody>
+          </p:sp>
+        </mc:Fallback>
+      </mc:AlternateContent>
+      <mc:AlternateContent xmlns:mc="http://schemas.openxmlformats.org/markup-compatibility/2006">
+        <mc:Choice xmlns:a14="http://schemas.microsoft.com/office/drawing/2010/main" Requires="a14">
+          <p:sp>
+            <p:nvSpPr>
+              <p:cNvPr id="6" name="Oval 5">
+                <a:extLst>
+                  <a:ext uri="{FF2B5EF4-FFF2-40B4-BE49-F238E27FC236}">
+                    <a16:creationId xmlns:a16="http://schemas.microsoft.com/office/drawing/2014/main" id="{FADAF1AB-4631-8177-1586-019E49D01782}"/>
+                  </a:ext>
+                </a:extLst>
+              </p:cNvPr>
+              <p:cNvSpPr/>
+              <p:nvPr/>
+            </p:nvSpPr>
+            <p:spPr>
+              <a:xfrm>
+                <a:off x="5080681" y="2151101"/>
+                <a:ext cx="1475014" cy="1475014"/>
+              </a:xfrm>
+              <a:prstGeom prst="ellipse">
+                <a:avLst/>
+              </a:prstGeom>
+              <a:solidFill>
+                <a:srgbClr val="9BCCF7"/>
+              </a:solidFill>
+            </p:spPr>
+            <p:style>
+              <a:lnRef idx="1">
+                <a:schemeClr val="dk1"/>
+              </a:lnRef>
+              <a:fillRef idx="2">
+                <a:schemeClr val="dk1"/>
+              </a:fillRef>
+              <a:effectRef idx="1">
+                <a:schemeClr val="dk1"/>
+              </a:effectRef>
+              <a:fontRef idx="minor">
+                <a:schemeClr val="dk1"/>
+              </a:fontRef>
+            </p:style>
+            <p:txBody>
+              <a:bodyPr rtlCol="0" anchor="ctr"/>
+              <a:lstStyle/>
+              <a:p>
+                <a:pPr algn="ctr"/>
+                <a14:m>
+                  <m:oMathPara xmlns:m="http://schemas.openxmlformats.org/officeDocument/2006/math">
+                    <m:oMathParaPr>
+                      <m:jc m:val="centerGroup"/>
+                    </m:oMathParaPr>
+                    <m:oMath xmlns:m="http://schemas.openxmlformats.org/officeDocument/2006/math">
+                      <m:sSub>
+                        <m:sSubPr>
+                          <m:ctrlPr>
+                            <a:rPr lang="en-US" b="0" i="1" smtClean="0">
+                              <a:latin typeface="Cambria Math" panose="02040503050406030204" pitchFamily="18" charset="0"/>
+                            </a:rPr>
+                          </m:ctrlPr>
+                        </m:sSubPr>
+                        <m:e>
+                          <m:r>
+                            <a:rPr lang="en-US" b="0" i="1" smtClean="0">
+                              <a:latin typeface="Cambria Math" panose="02040503050406030204" pitchFamily="18" charset="0"/>
+                            </a:rPr>
+                            <m:t>𝐺</m:t>
+                          </m:r>
+                        </m:e>
+                        <m:sub>
+                          <m:r>
+                            <a:rPr lang="en-US" b="0" i="1" smtClean="0">
+                              <a:latin typeface="Cambria Math" panose="02040503050406030204" pitchFamily="18" charset="0"/>
+                            </a:rPr>
+                            <m:t>𝑝𝑜𝑤𝑒𝑟</m:t>
+                          </m:r>
+                        </m:sub>
+                      </m:sSub>
+                    </m:oMath>
+                  </m:oMathPara>
+                </a14:m>
+                <a:endParaRPr lang="en-US" dirty="0"/>
+              </a:p>
+            </p:txBody>
+          </p:sp>
+        </mc:Choice>
+        <mc:Fallback>
+          <p:sp>
+            <p:nvSpPr>
+              <p:cNvPr id="6" name="Oval 5">
+                <a:extLst>
+                  <a:ext uri="{FF2B5EF4-FFF2-40B4-BE49-F238E27FC236}">
+                    <a16:creationId xmlns:a16="http://schemas.microsoft.com/office/drawing/2014/main" id="{FADAF1AB-4631-8177-1586-019E49D01782}"/>
+                  </a:ext>
+                </a:extLst>
+              </p:cNvPr>
+              <p:cNvSpPr>
+                <a:spLocks noRot="1" noChangeAspect="1" noMove="1" noResize="1" noEditPoints="1" noAdjustHandles="1" noChangeArrowheads="1" noChangeShapeType="1" noTextEdit="1"/>
+              </p:cNvSpPr>
+              <p:nvPr/>
+            </p:nvSpPr>
+            <p:spPr>
+              <a:xfrm>
+                <a:off x="5080681" y="2151101"/>
+                <a:ext cx="1475014" cy="1475014"/>
+              </a:xfrm>
+              <a:prstGeom prst="ellipse">
+                <a:avLst/>
+              </a:prstGeom>
+              <a:blipFill>
+                <a:blip r:embed="rId3"/>
+                <a:stretch>
+                  <a:fillRect/>
+                </a:stretch>
+              </a:blipFill>
+            </p:spPr>
+            <p:txBody>
+              <a:bodyPr/>
+              <a:lstStyle/>
+              <a:p>
+                <a:r>
+                  <a:rPr lang="en-US">
+                    <a:noFill/>
+                  </a:rPr>
+                  <a:t> </a:t>
+                </a:r>
+              </a:p>
+            </p:txBody>
+          </p:sp>
+        </mc:Fallback>
+      </mc:AlternateContent>
+      <mc:AlternateContent xmlns:mc="http://schemas.openxmlformats.org/markup-compatibility/2006">
+        <mc:Choice xmlns:a14="http://schemas.microsoft.com/office/drawing/2010/main" Requires="a14">
+          <p:sp>
+            <p:nvSpPr>
+              <p:cNvPr id="7" name="Oval 6">
+                <a:extLst>
+                  <a:ext uri="{FF2B5EF4-FFF2-40B4-BE49-F238E27FC236}">
+                    <a16:creationId xmlns:a16="http://schemas.microsoft.com/office/drawing/2014/main" id="{4DA3B9D1-B5EA-41D3-32D9-B78B91CD2E0E}"/>
+                  </a:ext>
+                </a:extLst>
+              </p:cNvPr>
+              <p:cNvSpPr/>
+              <p:nvPr/>
+            </p:nvSpPr>
+            <p:spPr>
+              <a:xfrm>
+                <a:off x="494273" y="3940237"/>
+                <a:ext cx="1475014" cy="1475014"/>
+              </a:xfrm>
+              <a:prstGeom prst="ellipse">
+                <a:avLst/>
+              </a:prstGeom>
+              <a:solidFill>
+                <a:srgbClr val="FFC000"/>
+              </a:solidFill>
+            </p:spPr>
+            <p:style>
+              <a:lnRef idx="1">
+                <a:schemeClr val="dk1"/>
+              </a:lnRef>
+              <a:fillRef idx="2">
+                <a:schemeClr val="dk1"/>
+              </a:fillRef>
+              <a:effectRef idx="1">
+                <a:schemeClr val="dk1"/>
+              </a:effectRef>
+              <a:fontRef idx="minor">
+                <a:schemeClr val="dk1"/>
+              </a:fontRef>
+            </p:style>
+            <p:txBody>
+              <a:bodyPr rtlCol="0" anchor="ctr"/>
+              <a:lstStyle/>
+              <a:p>
+                <a:pPr algn="ctr"/>
+                <a14:m>
+                  <m:oMathPara xmlns:m="http://schemas.openxmlformats.org/officeDocument/2006/math">
+                    <m:oMathParaPr>
+                      <m:jc m:val="centerGroup"/>
+                    </m:oMathParaPr>
+                    <m:oMath xmlns:m="http://schemas.openxmlformats.org/officeDocument/2006/math">
+                      <m:sSub>
+                        <m:sSubPr>
+                          <m:ctrlPr>
+                            <a:rPr lang="en-US" b="0" i="1" smtClean="0">
+                              <a:latin typeface="Cambria Math" panose="02040503050406030204" pitchFamily="18" charset="0"/>
+                            </a:rPr>
+                          </m:ctrlPr>
+                        </m:sSubPr>
+                        <m:e>
+                          <m:r>
+                            <a:rPr lang="en-US" b="0" i="1" smtClean="0">
+                              <a:latin typeface="Cambria Math" panose="02040503050406030204" pitchFamily="18" charset="0"/>
+                            </a:rPr>
+                            <m:t>𝑆</m:t>
+                          </m:r>
+                        </m:e>
+                        <m:sub>
+                          <m:r>
+                            <a:rPr lang="en-US" b="0" i="1" smtClean="0">
+                              <a:latin typeface="Cambria Math" panose="02040503050406030204" pitchFamily="18" charset="0"/>
+                            </a:rPr>
+                            <m:t>𝑖𝑟𝑟𝑎𝑑𝑖𝑎𝑛𝑐𝑒</m:t>
+                          </m:r>
+                        </m:sub>
+                      </m:sSub>
+                    </m:oMath>
+                  </m:oMathPara>
+                </a14:m>
+                <a:endParaRPr lang="en-US" dirty="0"/>
+              </a:p>
+            </p:txBody>
+          </p:sp>
+        </mc:Choice>
+        <mc:Fallback>
+          <p:sp>
+            <p:nvSpPr>
+              <p:cNvPr id="7" name="Oval 6">
+                <a:extLst>
+                  <a:ext uri="{FF2B5EF4-FFF2-40B4-BE49-F238E27FC236}">
+                    <a16:creationId xmlns:a16="http://schemas.microsoft.com/office/drawing/2014/main" id="{4DA3B9D1-B5EA-41D3-32D9-B78B91CD2E0E}"/>
+                  </a:ext>
+                </a:extLst>
+              </p:cNvPr>
+              <p:cNvSpPr>
+                <a:spLocks noRot="1" noChangeAspect="1" noMove="1" noResize="1" noEditPoints="1" noAdjustHandles="1" noChangeArrowheads="1" noChangeShapeType="1" noTextEdit="1"/>
+              </p:cNvSpPr>
+              <p:nvPr/>
+            </p:nvSpPr>
+            <p:spPr>
+              <a:xfrm>
+                <a:off x="494273" y="3940237"/>
+                <a:ext cx="1475014" cy="1475014"/>
+              </a:xfrm>
+              <a:prstGeom prst="ellipse">
+                <a:avLst/>
+              </a:prstGeom>
+              <a:blipFill>
+                <a:blip r:embed="rId4"/>
+                <a:stretch>
+                  <a:fillRect/>
+                </a:stretch>
+              </a:blipFill>
+            </p:spPr>
+            <p:txBody>
+              <a:bodyPr/>
+              <a:lstStyle/>
+              <a:p>
+                <a:r>
+                  <a:rPr lang="en-US">
+                    <a:noFill/>
+                  </a:rPr>
+                  <a:t> </a:t>
+                </a:r>
+              </a:p>
+            </p:txBody>
+          </p:sp>
+        </mc:Fallback>
+      </mc:AlternateContent>
+      <mc:AlternateContent xmlns:mc="http://schemas.openxmlformats.org/markup-compatibility/2006">
+        <mc:Choice xmlns:a14="http://schemas.microsoft.com/office/drawing/2010/main" Requires="a14">
+          <p:sp>
+            <p:nvSpPr>
+              <p:cNvPr id="8" name="Oval 7">
+                <a:extLst>
+                  <a:ext uri="{FF2B5EF4-FFF2-40B4-BE49-F238E27FC236}">
+                    <a16:creationId xmlns:a16="http://schemas.microsoft.com/office/drawing/2014/main" id="{E4C822F2-E0A0-1449-A1CA-2E61E7551947}"/>
+                  </a:ext>
+                </a:extLst>
+              </p:cNvPr>
+              <p:cNvSpPr/>
+              <p:nvPr/>
+            </p:nvSpPr>
+            <p:spPr>
+              <a:xfrm>
+                <a:off x="4979366" y="5252217"/>
+                <a:ext cx="1475014" cy="1475014"/>
+              </a:xfrm>
+              <a:prstGeom prst="ellipse">
+                <a:avLst/>
+              </a:prstGeom>
+            </p:spPr>
+            <p:style>
+              <a:lnRef idx="2">
+                <a:schemeClr val="dk1"/>
+              </a:lnRef>
+              <a:fillRef idx="1">
+                <a:schemeClr val="lt1"/>
+              </a:fillRef>
+              <a:effectRef idx="0">
+                <a:schemeClr val="dk1"/>
+              </a:effectRef>
+              <a:fontRef idx="minor">
+                <a:schemeClr val="dk1"/>
+              </a:fontRef>
+            </p:style>
+            <p:txBody>
+              <a:bodyPr rtlCol="0" anchor="ctr"/>
+              <a:lstStyle/>
+              <a:p>
+                <a:pPr algn="ctr"/>
+                <a14:m>
+                  <m:oMathPara xmlns:m="http://schemas.openxmlformats.org/officeDocument/2006/math">
+                    <m:oMathParaPr>
+                      <m:jc m:val="centerGroup"/>
+                    </m:oMathParaPr>
+                    <m:oMath xmlns:m="http://schemas.openxmlformats.org/officeDocument/2006/math">
+                      <m:f>
+                        <m:fPr>
+                          <m:ctrlPr>
+                            <a:rPr lang="en-US" b="0" i="1" smtClean="0">
+                              <a:latin typeface="Cambria Math" panose="02040503050406030204" pitchFamily="18" charset="0"/>
+                            </a:rPr>
+                          </m:ctrlPr>
+                        </m:fPr>
+                        <m:num>
+                          <m:r>
+                            <a:rPr lang="en-US" b="0" i="1" smtClean="0">
+                              <a:latin typeface="Cambria Math" panose="02040503050406030204" pitchFamily="18" charset="0"/>
+                            </a:rPr>
+                            <m:t>𝐻𝑒𝑎𝑡𝑖𝑛𝑔</m:t>
+                          </m:r>
+                        </m:num>
+                        <m:den>
+                          <m:r>
+                            <a:rPr lang="en-US" b="0" i="1" smtClean="0">
+                              <a:latin typeface="Cambria Math" panose="02040503050406030204" pitchFamily="18" charset="0"/>
+                            </a:rPr>
+                            <m:t>𝐶𝑜𝑜𝑙𝑖𝑛𝑔</m:t>
+                          </m:r>
+                          <m:r>
+                            <a:rPr lang="en-US" b="0" i="1" smtClean="0">
+                              <a:latin typeface="Cambria Math" panose="02040503050406030204" pitchFamily="18" charset="0"/>
+                            </a:rPr>
+                            <m:t> </m:t>
+                          </m:r>
+                        </m:den>
+                      </m:f>
+                    </m:oMath>
+                  </m:oMathPara>
+                </a14:m>
+                <a:endParaRPr lang="en-US" dirty="0"/>
+              </a:p>
+            </p:txBody>
+          </p:sp>
+        </mc:Choice>
+        <mc:Fallback>
+          <p:sp>
+            <p:nvSpPr>
+              <p:cNvPr id="8" name="Oval 7">
+                <a:extLst>
+                  <a:ext uri="{FF2B5EF4-FFF2-40B4-BE49-F238E27FC236}">
+                    <a16:creationId xmlns:a16="http://schemas.microsoft.com/office/drawing/2014/main" id="{E4C822F2-E0A0-1449-A1CA-2E61E7551947}"/>
+                  </a:ext>
+                </a:extLst>
+              </p:cNvPr>
+              <p:cNvSpPr>
+                <a:spLocks noRot="1" noChangeAspect="1" noMove="1" noResize="1" noEditPoints="1" noAdjustHandles="1" noChangeArrowheads="1" noChangeShapeType="1" noTextEdit="1"/>
+              </p:cNvSpPr>
+              <p:nvPr/>
+            </p:nvSpPr>
+            <p:spPr>
+              <a:xfrm>
+                <a:off x="4979366" y="5252217"/>
+                <a:ext cx="1475014" cy="1475014"/>
+              </a:xfrm>
+              <a:prstGeom prst="ellipse">
+                <a:avLst/>
+              </a:prstGeom>
+              <a:blipFill>
+                <a:blip r:embed="rId5"/>
+                <a:stretch>
+                  <a:fillRect/>
+                </a:stretch>
+              </a:blipFill>
+            </p:spPr>
+            <p:txBody>
+              <a:bodyPr/>
+              <a:lstStyle/>
+              <a:p>
+                <a:r>
+                  <a:rPr lang="en-US">
+                    <a:noFill/>
+                  </a:rPr>
+                  <a:t> </a:t>
+                </a:r>
+              </a:p>
+            </p:txBody>
+          </p:sp>
+        </mc:Fallback>
+      </mc:AlternateContent>
+      <p:cxnSp>
+        <p:nvCxnSpPr>
+          <p:cNvPr id="9" name="Straight Arrow Connector 8">
+            <a:extLst>
+              <a:ext uri="{FF2B5EF4-FFF2-40B4-BE49-F238E27FC236}">
+                <a16:creationId xmlns:a16="http://schemas.microsoft.com/office/drawing/2014/main" id="{E933E1CC-73E4-D30B-B3BE-50A2923674DF}"/>
+              </a:ext>
+            </a:extLst>
+          </p:cNvPr>
+          <p:cNvCxnSpPr/>
+          <p:nvPr/>
+        </p:nvCxnSpPr>
+        <p:spPr>
+          <a:xfrm flipV="1">
+            <a:off x="4364576" y="3410104"/>
+            <a:ext cx="932116" cy="724764"/>
+          </a:xfrm>
+          <a:prstGeom prst="straightConnector1">
+            <a:avLst/>
+          </a:prstGeom>
+          <a:ln>
+            <a:tailEnd type="triangle"/>
+          </a:ln>
+        </p:spPr>
+        <p:style>
+          <a:lnRef idx="2">
+            <a:schemeClr val="dk1"/>
+          </a:lnRef>
+          <a:fillRef idx="0">
+            <a:schemeClr val="dk1"/>
+          </a:fillRef>
+          <a:effectRef idx="1">
+            <a:schemeClr val="dk1"/>
+          </a:effectRef>
+          <a:fontRef idx="minor">
+            <a:schemeClr val="tx1"/>
+          </a:fontRef>
+        </p:style>
+      </p:cxnSp>
+      <p:cxnSp>
+        <p:nvCxnSpPr>
+          <p:cNvPr id="11" name="Straight Arrow Connector 10">
+            <a:extLst>
+              <a:ext uri="{FF2B5EF4-FFF2-40B4-BE49-F238E27FC236}">
+                <a16:creationId xmlns:a16="http://schemas.microsoft.com/office/drawing/2014/main" id="{0910F1BD-8AF5-3304-10A3-75FC5A3631D8}"/>
+              </a:ext>
+            </a:extLst>
+          </p:cNvPr>
+          <p:cNvCxnSpPr>
+            <a:cxnSpLocks/>
+          </p:cNvCxnSpPr>
+          <p:nvPr/>
+        </p:nvCxnSpPr>
+        <p:spPr>
+          <a:xfrm flipV="1">
+            <a:off x="1753276" y="2888608"/>
+            <a:ext cx="3327405" cy="1267640"/>
+          </a:xfrm>
+          <a:prstGeom prst="straightConnector1">
+            <a:avLst/>
+          </a:prstGeom>
+          <a:ln>
+            <a:tailEnd type="triangle"/>
+          </a:ln>
+        </p:spPr>
+        <p:style>
+          <a:lnRef idx="2">
+            <a:schemeClr val="dk1"/>
+          </a:lnRef>
+          <a:fillRef idx="0">
+            <a:schemeClr val="dk1"/>
+          </a:fillRef>
+          <a:effectRef idx="1">
+            <a:schemeClr val="dk1"/>
+          </a:effectRef>
+          <a:fontRef idx="minor">
+            <a:schemeClr val="tx1"/>
+          </a:fontRef>
+        </p:style>
+      </p:cxnSp>
+      <p:cxnSp>
+        <p:nvCxnSpPr>
+          <p:cNvPr id="13" name="Straight Arrow Connector 12">
+            <a:extLst>
+              <a:ext uri="{FF2B5EF4-FFF2-40B4-BE49-F238E27FC236}">
+                <a16:creationId xmlns:a16="http://schemas.microsoft.com/office/drawing/2014/main" id="{48982866-D80C-2F19-CC37-90CE194AD870}"/>
+              </a:ext>
+            </a:extLst>
+          </p:cNvPr>
+          <p:cNvCxnSpPr>
+            <a:cxnSpLocks/>
+          </p:cNvCxnSpPr>
+          <p:nvPr/>
+        </p:nvCxnSpPr>
+        <p:spPr>
+          <a:xfrm flipV="1">
+            <a:off x="5716873" y="3626115"/>
+            <a:ext cx="101315" cy="1626102"/>
+          </a:xfrm>
+          <a:prstGeom prst="straightConnector1">
+            <a:avLst/>
+          </a:prstGeom>
+          <a:ln>
+            <a:tailEnd type="triangle"/>
+          </a:ln>
+        </p:spPr>
+        <p:style>
+          <a:lnRef idx="2">
+            <a:schemeClr val="dk1"/>
+          </a:lnRef>
+          <a:fillRef idx="0">
+            <a:schemeClr val="dk1"/>
+          </a:fillRef>
+          <a:effectRef idx="1">
+            <a:schemeClr val="dk1"/>
+          </a:effectRef>
+          <a:fontRef idx="minor">
+            <a:schemeClr val="tx1"/>
+          </a:fontRef>
+        </p:style>
+      </p:cxnSp>
+      <p:sp>
+        <p:nvSpPr>
+          <p:cNvPr id="14" name="TextBox 13">
+            <a:extLst>
+              <a:ext uri="{FF2B5EF4-FFF2-40B4-BE49-F238E27FC236}">
+                <a16:creationId xmlns:a16="http://schemas.microsoft.com/office/drawing/2014/main" id="{2258181E-F263-9D60-061F-27433A0C9266}"/>
+              </a:ext>
+            </a:extLst>
+          </p:cNvPr>
+          <p:cNvSpPr txBox="1"/>
+          <p:nvPr/>
+        </p:nvSpPr>
+        <p:spPr>
+          <a:xfrm>
+            <a:off x="870857" y="1001486"/>
+            <a:ext cx="1405834" cy="369332"/>
+          </a:xfrm>
+          <a:prstGeom prst="rect">
+            <a:avLst/>
+          </a:prstGeom>
+          <a:noFill/>
+        </p:spPr>
+        <p:txBody>
+          <a:bodyPr wrap="none" rtlCol="0">
+            <a:spAutoFit/>
+          </a:bodyPr>
+          <a:lstStyle/>
+          <a:p>
+            <a:r>
+              <a:rPr lang="en-US" dirty="0"/>
+              <a:t>Solar Power </a:t>
+            </a:r>
+          </a:p>
+        </p:txBody>
+      </p:sp>
+    </p:spTree>
+    <p:extLst>
+      <p:ext uri="{BB962C8B-B14F-4D97-AF65-F5344CB8AC3E}">
+        <p14:creationId xmlns:p14="http://schemas.microsoft.com/office/powerpoint/2010/main" val="1169359206"/>
       </p:ext>
     </p:extLst>
   </p:cSld>

</xml_diff>